<commit_message>
docs(f4): incorpora las notas del orador en cada diapositiva
- Las diez laminas llevan el guion como notas del orador, visibles en la
  vista Presentador y en la impresion con notas.
- GUION_PRESENTACION_F4.md se genera de la misma fuente que las notas,
  de modo que documento y archivo no pueden divergir.
- Narracion ajustada a 973 palabras: entre 6:23 y 7:55 segun el ritmo,
  dentro del rango exigido de 5 a 8 minutos.
</commit_message>
<xml_diff>
--- a/informe/Presentacion_Fase4_Sebastian_Antunez.pptx
+++ b/informe/Presentacion_Fase4_Sebastian_Antunez.pptx
@@ -475,6 +475,1175 @@
     </a:lvl9pPr>
   </p:notesStyle>
 </p:notesMaster>
+</file>
+
+<file path=ppt/notesSlides/notesSlide1.xml><?xml version="1.0" encoding="utf-8"?>
+<p:notes xmlns:a="http://schemas.openxmlformats.org/drawingml/2006/main" xmlns:p="http://schemas.openxmlformats.org/presentationml/2006/main" xmlns:r="http://schemas.openxmlformats.org/officeDocument/2006/relationships">
+  <p:cSld>
+    <p:spTree>
+      <p:nvGrpSpPr>
+        <p:cNvPr id="1" name=""/>
+        <p:cNvGrpSpPr/>
+        <p:nvPr/>
+      </p:nvGrpSpPr>
+      <p:grpSpPr>
+        <a:xfrm>
+          <a:off x="0" y="0"/>
+          <a:ext cx="0" cy="0"/>
+          <a:chOff x="0" y="0"/>
+          <a:chExt cx="0" cy="0"/>
+        </a:xfrm>
+      </p:grpSpPr>
+      <p:sp>
+        <p:nvSpPr>
+          <p:cNvPr id="2" name="Slide Image Placeholder 1"/>
+          <p:cNvSpPr>
+            <a:spLocks noGrp="1"/>
+          </p:cNvSpPr>
+          <p:nvPr>
+            <p:ph type="sldImg" idx="2"/>
+          </p:nvPr>
+        </p:nvSpPr>
+        <p:spPr/>
+      </p:sp>
+      <p:sp>
+        <p:nvSpPr>
+          <p:cNvPr id="3" name="Notes Placeholder 2"/>
+          <p:cNvSpPr>
+            <a:spLocks noGrp="1"/>
+          </p:cNvSpPr>
+          <p:nvPr>
+            <p:ph type="body" idx="3" sz="quarter"/>
+          </p:nvPr>
+        </p:nvSpPr>
+        <p:spPr/>
+        <p:txBody>
+          <a:bodyPr/>
+          <a:lstStyle/>
+          <a:p>
+            <a:r>
+              <a:t>[0:00 - 0:20 · 20 s]</a:t>
+            </a:r>
+          </a:p>
+          <a:p/>
+          <a:p>
+            <a:r>
+              <a:t>Buenos días. Mi nombre es Sebastian Antunez y voy a presentar el proyecto final del</a:t>
+            </a:r>
+          </a:p>
+          <a:p>
+            <a:r>
+              <a:t>curso Programación para la Ciencia de Datos: un análisis sobre la sobreduración en la</a:t>
+            </a:r>
+          </a:p>
+          <a:p>
+            <a:r>
+              <a:t>titulación de la educación superior chilena, construido sobre 1.246.760 procesos de</a:t>
+            </a:r>
+          </a:p>
+          <a:p>
+            <a:r>
+              <a:t>titulación reales entre 2020 y 2025.</a:t>
+            </a:r>
+          </a:p>
+          <a:p/>
+          <a:p>
+            <a:r>
+              <a:t>RECORDAR: hablar más lento de lo que parece natural; en grabación siempre suena más rápido.</a:t>
+            </a:r>
+          </a:p>
+        </p:txBody>
+      </p:sp>
+      <p:sp>
+        <p:nvSpPr>
+          <p:cNvPr id="4" name="Slide Number Placeholder 3"/>
+          <p:cNvSpPr>
+            <a:spLocks noGrp="1"/>
+          </p:cNvSpPr>
+          <p:nvPr>
+            <p:ph type="sldNum" idx="5" sz="quarter"/>
+          </p:nvPr>
+        </p:nvSpPr>
+        <p:spPr/>
+      </p:sp>
+    </p:spTree>
+  </p:cSld>
+  <p:clrMapOvr>
+    <a:masterClrMapping/>
+  </p:clrMapOvr>
+</p:notes>
+</file>
+
+<file path=ppt/notesSlides/notesSlide10.xml><?xml version="1.0" encoding="utf-8"?>
+<p:notes xmlns:a="http://schemas.openxmlformats.org/drawingml/2006/main" xmlns:p="http://schemas.openxmlformats.org/presentationml/2006/main" xmlns:r="http://schemas.openxmlformats.org/officeDocument/2006/relationships">
+  <p:cSld>
+    <p:spTree>
+      <p:nvGrpSpPr>
+        <p:cNvPr id="1" name=""/>
+        <p:cNvGrpSpPr/>
+        <p:nvPr/>
+      </p:nvGrpSpPr>
+      <p:grpSpPr>
+        <a:xfrm>
+          <a:off x="0" y="0"/>
+          <a:ext cx="0" cy="0"/>
+          <a:chOff x="0" y="0"/>
+          <a:chExt cx="0" cy="0"/>
+        </a:xfrm>
+      </p:grpSpPr>
+      <p:sp>
+        <p:nvSpPr>
+          <p:cNvPr id="2" name="Slide Image Placeholder 1"/>
+          <p:cNvSpPr>
+            <a:spLocks noGrp="1"/>
+          </p:cNvSpPr>
+          <p:nvPr>
+            <p:ph type="sldImg" idx="2"/>
+          </p:nvPr>
+        </p:nvSpPr>
+        <p:spPr/>
+      </p:sp>
+      <p:sp>
+        <p:nvSpPr>
+          <p:cNvPr id="3" name="Notes Placeholder 2"/>
+          <p:cNvSpPr>
+            <a:spLocks noGrp="1"/>
+          </p:cNvSpPr>
+          <p:nvPr>
+            <p:ph type="body" idx="3" sz="quarter"/>
+          </p:nvPr>
+        </p:nvSpPr>
+        <p:spPr/>
+        <p:txBody>
+          <a:bodyPr/>
+          <a:lstStyle/>
+          <a:p>
+            <a:r>
+              <a:t>[6:55 - 7:10 · 15 s]</a:t>
+            </a:r>
+          </a:p>
+          <a:p/>
+          <a:p>
+            <a:r>
+              <a:t>Lo que queda para seguir: incorporar la base de matrícula para ver la deserción, que hoy</a:t>
+            </a:r>
+          </a:p>
+          <a:p>
+            <a:r>
+              <a:t>es invisible; usar modelos de supervivencia, que son los adecuados para datos</a:t>
+            </a:r>
+          </a:p>
+          <a:p>
+            <a:r>
+              <a:t>censurados; y ampliar las variables hacia la trayectoria individual.</a:t>
+            </a:r>
+          </a:p>
+          <a:p/>
+          <a:p>
+            <a:r>
+              <a:t>El repositorio completo está disponible en GitHub. Muchas gracias.</a:t>
+            </a:r>
+          </a:p>
+        </p:txBody>
+      </p:sp>
+      <p:sp>
+        <p:nvSpPr>
+          <p:cNvPr id="4" name="Slide Number Placeholder 3"/>
+          <p:cNvSpPr>
+            <a:spLocks noGrp="1"/>
+          </p:cNvSpPr>
+          <p:nvPr>
+            <p:ph type="sldNum" idx="5" sz="quarter"/>
+          </p:nvPr>
+        </p:nvSpPr>
+        <p:spPr/>
+      </p:sp>
+    </p:spTree>
+  </p:cSld>
+  <p:clrMapOvr>
+    <a:masterClrMapping/>
+  </p:clrMapOvr>
+</p:notes>
+</file>
+
+<file path=ppt/notesSlides/notesSlide2.xml><?xml version="1.0" encoding="utf-8"?>
+<p:notes xmlns:a="http://schemas.openxmlformats.org/drawingml/2006/main" xmlns:p="http://schemas.openxmlformats.org/presentationml/2006/main" xmlns:r="http://schemas.openxmlformats.org/officeDocument/2006/relationships">
+  <p:cSld>
+    <p:spTree>
+      <p:nvGrpSpPr>
+        <p:cNvPr id="1" name=""/>
+        <p:cNvGrpSpPr/>
+        <p:nvPr/>
+      </p:nvGrpSpPr>
+      <p:grpSpPr>
+        <a:xfrm>
+          <a:off x="0" y="0"/>
+          <a:ext cx="0" cy="0"/>
+          <a:chOff x="0" y="0"/>
+          <a:chExt cx="0" cy="0"/>
+        </a:xfrm>
+      </p:grpSpPr>
+      <p:sp>
+        <p:nvSpPr>
+          <p:cNvPr id="2" name="Slide Image Placeholder 1"/>
+          <p:cNvSpPr>
+            <a:spLocks noGrp="1"/>
+          </p:cNvSpPr>
+          <p:nvPr>
+            <p:ph type="sldImg" idx="2"/>
+          </p:nvPr>
+        </p:nvSpPr>
+        <p:spPr/>
+      </p:sp>
+      <p:sp>
+        <p:nvSpPr>
+          <p:cNvPr id="3" name="Notes Placeholder 2"/>
+          <p:cNvSpPr>
+            <a:spLocks noGrp="1"/>
+          </p:cNvSpPr>
+          <p:nvPr>
+            <p:ph type="body" idx="3" sz="quarter"/>
+          </p:nvPr>
+        </p:nvSpPr>
+        <p:spPr/>
+        <p:txBody>
+          <a:bodyPr/>
+          <a:lstStyle/>
+          <a:p>
+            <a:r>
+              <a:t>[0:20 - 1:10 · 50 s]</a:t>
+            </a:r>
+          </a:p>
+          <a:p/>
+          <a:p>
+            <a:r>
+              <a:t>Cada carrera en Chile declara una duración teórica. Sobre esa cifra se calculan la</a:t>
+            </a:r>
+          </a:p>
+          <a:p>
+            <a:r>
+              <a:t>duración de las becas y los créditos estatales.</a:t>
+            </a:r>
+          </a:p>
+          <a:p/>
+          <a:p>
+            <a:r>
+              <a:t>Lo que el sistema no publica es cuánto se tarda en realidad. Y aquí está el punto de</a:t>
+            </a:r>
+          </a:p>
+          <a:p>
+            <a:r>
+              <a:t>partida: al revisar el esquema oficial del SIES descubrí que las columnas que parecían</a:t>
+            </a:r>
+          </a:p>
+          <a:p>
+            <a:r>
+              <a:t>tener la respuesta NO registran lo que el estudiante tardó, sino lo que el plan declara.</a:t>
+            </a:r>
+          </a:p>
+          <a:p>
+            <a:r>
+              <a:t>Son un atributo de la carrera, no de la persona.</a:t>
+            </a:r>
+          </a:p>
+          <a:p/>
+          <a:p>
+            <a:r>
+              <a:t>Así que la pregunta fue: se puede reconstruir la duración real desde los registros</a:t>
+            </a:r>
+          </a:p>
+          <a:p>
+            <a:r>
+              <a:t>administrativos, y caracterizar el rezago con esa variable derivada.</a:t>
+            </a:r>
+          </a:p>
+          <a:p/>
+          <a:p>
+            <a:r>
+              <a:t>PAUSA de medio segundo antes de avanzar: es la bisagra del relato.</a:t>
+            </a:r>
+          </a:p>
+        </p:txBody>
+      </p:sp>
+      <p:sp>
+        <p:nvSpPr>
+          <p:cNvPr id="4" name="Slide Number Placeholder 3"/>
+          <p:cNvSpPr>
+            <a:spLocks noGrp="1"/>
+          </p:cNvSpPr>
+          <p:nvPr>
+            <p:ph type="sldNum" idx="5" sz="quarter"/>
+          </p:nvPr>
+        </p:nvSpPr>
+        <p:spPr/>
+      </p:sp>
+    </p:spTree>
+  </p:cSld>
+  <p:clrMapOvr>
+    <a:masterClrMapping/>
+  </p:clrMapOvr>
+</p:notes>
+</file>
+
+<file path=ppt/notesSlides/notesSlide3.xml><?xml version="1.0" encoding="utf-8"?>
+<p:notes xmlns:a="http://schemas.openxmlformats.org/drawingml/2006/main" xmlns:p="http://schemas.openxmlformats.org/presentationml/2006/main" xmlns:r="http://schemas.openxmlformats.org/officeDocument/2006/relationships">
+  <p:cSld>
+    <p:spTree>
+      <p:nvGrpSpPr>
+        <p:cNvPr id="1" name=""/>
+        <p:cNvGrpSpPr/>
+        <p:nvPr/>
+      </p:nvGrpSpPr>
+      <p:grpSpPr>
+        <a:xfrm>
+          <a:off x="0" y="0"/>
+          <a:ext cx="0" cy="0"/>
+          <a:chOff x="0" y="0"/>
+          <a:chExt cx="0" cy="0"/>
+        </a:xfrm>
+      </p:grpSpPr>
+      <p:sp>
+        <p:nvSpPr>
+          <p:cNvPr id="2" name="Slide Image Placeholder 1"/>
+          <p:cNvSpPr>
+            <a:spLocks noGrp="1"/>
+          </p:cNvSpPr>
+          <p:nvPr>
+            <p:ph type="sldImg" idx="2"/>
+          </p:nvPr>
+        </p:nvSpPr>
+        <p:spPr/>
+      </p:sp>
+      <p:sp>
+        <p:nvSpPr>
+          <p:cNvPr id="3" name="Notes Placeholder 2"/>
+          <p:cNvSpPr>
+            <a:spLocks noGrp="1"/>
+          </p:cNvSpPr>
+          <p:nvPr>
+            <p:ph type="body" idx="3" sz="quarter"/>
+          </p:nvPr>
+        </p:nvSpPr>
+        <p:spPr/>
+        <p:txBody>
+          <a:bodyPr/>
+          <a:lstStyle/>
+          <a:p>
+            <a:r>
+              <a:t>[1:10 - 2:10 · 60 s]</a:t>
+            </a:r>
+          </a:p>
+          <a:p/>
+          <a:p>
+            <a:r>
+              <a:t>El proyecto se desarrolló en cuatro fases. La primera definió el problema y levantó el</a:t>
+            </a:r>
+          </a:p>
+          <a:p>
+            <a:r>
+              <a:t>entorno reproducible. La segunda construyó el pipeline que convierte 955 megabytes de</a:t>
+            </a:r>
+          </a:p>
+          <a:p>
+            <a:r>
+              <a:t>archivos crudos en un conjunto analítico validado. La tercera implementó el núcleo</a:t>
+            </a:r>
+          </a:p>
+          <a:p>
+            <a:r>
+              <a:t>algorítmico desde primeros principios, con medición formal de complejidad y un modelo de</a:t>
+            </a:r>
+          </a:p>
+          <a:p>
+            <a:r>
+              <a:t>dominio orientado a objetos. Y la cuarta, que es la que presento, ejecuta todo eso de</a:t>
+            </a:r>
+          </a:p>
+          <a:p>
+            <a:r>
+              <a:t>extremo a extremo.</a:t>
+            </a:r>
+          </a:p>
+          <a:p/>
+          <a:p>
+            <a:r>
+              <a:t>La transformación central está abajo: la duración real se deriva del año y semestre de</a:t>
+            </a:r>
+          </a:p>
+          <a:p>
+            <a:r>
+              <a:t>ingreso y de titulación. El "más uno" no es arbitrario: quien ingresa y se titula en el</a:t>
+            </a:r>
+          </a:p>
+          <a:p>
+            <a:r>
+              <a:t>mismo semestre cursó un semestre, no cero. Esa coherencia aritmética se verifica como</a:t>
+            </a:r>
+          </a:p>
+          <a:p>
+            <a:r>
+              <a:t>regla de validación sobre el dataset completo.</a:t>
+            </a:r>
+          </a:p>
+          <a:p/>
+          <a:p>
+            <a:r>
+              <a:t>SI EL VIDEO VA CORTO, agregar aquí: el pipeline retiene el 72,9 por ciento de las filas</a:t>
+            </a:r>
+          </a:p>
+          <a:p>
+            <a:r>
+              <a:t>originales y cada exclusión está cuantificada en una bitácora auditable.</a:t>
+            </a:r>
+          </a:p>
+        </p:txBody>
+      </p:sp>
+      <p:sp>
+        <p:nvSpPr>
+          <p:cNvPr id="4" name="Slide Number Placeholder 3"/>
+          <p:cNvSpPr>
+            <a:spLocks noGrp="1"/>
+          </p:cNvSpPr>
+          <p:nvPr>
+            <p:ph type="sldNum" idx="5" sz="quarter"/>
+          </p:nvPr>
+        </p:nvSpPr>
+        <p:spPr/>
+      </p:sp>
+    </p:spTree>
+  </p:cSld>
+  <p:clrMapOvr>
+    <a:masterClrMapping/>
+  </p:clrMapOvr>
+</p:notes>
+</file>
+
+<file path=ppt/notesSlides/notesSlide4.xml><?xml version="1.0" encoding="utf-8"?>
+<p:notes xmlns:a="http://schemas.openxmlformats.org/drawingml/2006/main" xmlns:p="http://schemas.openxmlformats.org/presentationml/2006/main" xmlns:r="http://schemas.openxmlformats.org/officeDocument/2006/relationships">
+  <p:cSld>
+    <p:spTree>
+      <p:nvGrpSpPr>
+        <p:cNvPr id="1" name=""/>
+        <p:cNvGrpSpPr/>
+        <p:nvPr/>
+      </p:nvGrpSpPr>
+      <p:grpSpPr>
+        <a:xfrm>
+          <a:off x="0" y="0"/>
+          <a:ext cx="0" cy="0"/>
+          <a:chOff x="0" y="0"/>
+          <a:chExt cx="0" cy="0"/>
+        </a:xfrm>
+      </p:grpSpPr>
+      <p:sp>
+        <p:nvSpPr>
+          <p:cNvPr id="2" name="Slide Image Placeholder 1"/>
+          <p:cNvSpPr>
+            <a:spLocks noGrp="1"/>
+          </p:cNvSpPr>
+          <p:nvPr>
+            <p:ph type="sldImg" idx="2"/>
+          </p:nvPr>
+        </p:nvSpPr>
+        <p:spPr/>
+      </p:sp>
+      <p:sp>
+        <p:nvSpPr>
+          <p:cNvPr id="3" name="Notes Placeholder 2"/>
+          <p:cNvSpPr>
+            <a:spLocks noGrp="1"/>
+          </p:cNvSpPr>
+          <p:nvPr>
+            <p:ph type="body" idx="3" sz="quarter"/>
+          </p:nvPr>
+        </p:nvSpPr>
+        <p:spPr/>
+        <p:txBody>
+          <a:bodyPr/>
+          <a:lstStyle/>
+          <a:p>
+            <a:r>
+              <a:t>[2:10 - 3:05 · 55 s]</a:t>
+            </a:r>
+          </a:p>
+          <a:p/>
+          <a:p>
+            <a:r>
+              <a:t>Este es el resultado central. Solo el 19 por ciento de los titulados egresa dentro del</a:t>
+            </a:r>
+          </a:p>
+          <a:p>
+            <a:r>
+              <a:t>plazo que su propio plan declara. Dicho al revés: cuatro de cada cinco se titulan fuera</a:t>
+            </a:r>
+          </a:p>
+          <a:p>
+            <a:r>
+              <a:t>de plazo.</a:t>
+            </a:r>
+          </a:p>
+          <a:p/>
+          <a:p>
+            <a:r>
+              <a:t>El exceso promedio es de 2 coma 76 semestres, un 43 por ciento más de tiempo del</a:t>
+            </a:r>
+          </a:p>
+          <a:p>
+            <a:r>
+              <a:t>previsto. Y el rezago severo, más de cuatro semestres de exceso, alcanza al 20 coma 4</a:t>
+            </a:r>
+          </a:p>
+          <a:p>
+            <a:r>
+              <a:t>por ciento: prácticamente la misma proporción que logra titularse a tiempo.</a:t>
+            </a:r>
+          </a:p>
+          <a:p/>
+          <a:p>
+            <a:r>
+              <a:t>Agregado, el sistema acumula 3 coma 55 millones de semestres-estudiante por sobre lo</a:t>
+            </a:r>
+          </a:p>
+          <a:p>
+            <a:r>
+              <a:t>planificado en el período.</a:t>
+            </a:r>
+          </a:p>
+          <a:p/>
+          <a:p>
+            <a:r>
+              <a:t>El gráfico de la izquierda muestra por qué reporto media y mediana: la distribución es</a:t>
+            </a:r>
+          </a:p>
+          <a:p>
+            <a:r>
+              <a:t>asimétrica, con una cola larga que arrastra el promedio.</a:t>
+            </a:r>
+          </a:p>
+        </p:txBody>
+      </p:sp>
+      <p:sp>
+        <p:nvSpPr>
+          <p:cNvPr id="4" name="Slide Number Placeholder 3"/>
+          <p:cNvSpPr>
+            <a:spLocks noGrp="1"/>
+          </p:cNvSpPr>
+          <p:nvPr>
+            <p:ph type="sldNum" idx="5" sz="quarter"/>
+          </p:nvPr>
+        </p:nvSpPr>
+        <p:spPr/>
+      </p:sp>
+    </p:spTree>
+  </p:cSld>
+  <p:clrMapOvr>
+    <a:masterClrMapping/>
+  </p:clrMapOvr>
+</p:notes>
+</file>
+
+<file path=ppt/notesSlides/notesSlide5.xml><?xml version="1.0" encoding="utf-8"?>
+<p:notes xmlns:a="http://schemas.openxmlformats.org/drawingml/2006/main" xmlns:p="http://schemas.openxmlformats.org/presentationml/2006/main" xmlns:r="http://schemas.openxmlformats.org/officeDocument/2006/relationships">
+  <p:cSld>
+    <p:spTree>
+      <p:nvGrpSpPr>
+        <p:cNvPr id="1" name=""/>
+        <p:cNvGrpSpPr/>
+        <p:nvPr/>
+      </p:nvGrpSpPr>
+      <p:grpSpPr>
+        <a:xfrm>
+          <a:off x="0" y="0"/>
+          <a:ext cx="0" cy="0"/>
+          <a:chOff x="0" y="0"/>
+          <a:chExt cx="0" cy="0"/>
+        </a:xfrm>
+      </p:grpSpPr>
+      <p:sp>
+        <p:nvSpPr>
+          <p:cNvPr id="2" name="Slide Image Placeholder 1"/>
+          <p:cNvSpPr>
+            <a:spLocks noGrp="1"/>
+          </p:cNvSpPr>
+          <p:nvPr>
+            <p:ph type="sldImg" idx="2"/>
+          </p:nvPr>
+        </p:nvSpPr>
+        <p:spPr/>
+      </p:sp>
+      <p:sp>
+        <p:nvSpPr>
+          <p:cNvPr id="3" name="Notes Placeholder 2"/>
+          <p:cNvSpPr>
+            <a:spLocks noGrp="1"/>
+          </p:cNvSpPr>
+          <p:nvPr>
+            <p:ph type="body" idx="3" sz="quarter"/>
+          </p:nvPr>
+        </p:nvSpPr>
+        <p:spPr/>
+        <p:txBody>
+          <a:bodyPr/>
+          <a:lstStyle/>
+          <a:p>
+            <a:r>
+              <a:t>[3:05 - 4:05 · 60 s]</a:t>
+            </a:r>
+          </a:p>
+          <a:p/>
+          <a:p>
+            <a:r>
+              <a:t>El rezago tampoco se reparte de forma pareja.</a:t>
+            </a:r>
+          </a:p>
+          <a:p/>
+          <a:p>
+            <a:r>
+              <a:t>Por área de conocimiento, Derecho triplica a Educación: 5,77 semestres frente a 1,93.</a:t>
+            </a:r>
+          </a:p>
+          <a:p>
+            <a:r>
+              <a:t>Casi cuatro semestres, dos años, separan a la carrera más rezagada de la menos rezagada.</a:t>
+            </a:r>
+          </a:p>
+          <a:p/>
+          <a:p>
+            <a:r>
+              <a:t>Por tipo de institución, las universidades acumulan más rezago que los institutos</a:t>
+            </a:r>
+          </a:p>
+          <a:p>
+            <a:r>
+              <a:t>profesionales y su tasa de titulación oportuna es menos de la mitad. Eso sugiere que la</a:t>
+            </a:r>
+          </a:p>
+          <a:p>
+            <a:r>
+              <a:t>duración declarada es menos realista en carreras universitarias largas.</a:t>
+            </a:r>
+          </a:p>
+          <a:p/>
+          <a:p>
+            <a:r>
+              <a:t>Y por género, las mujeres se titulan 0 coma 93 semestres antes. Lo importante del panel</a:t>
+            </a:r>
+          </a:p>
+          <a:p>
+            <a:r>
+              <a:t>derecho es que la brecha se sostiene en las diez áreas sin excepción: no es que estudien</a:t>
+            </a:r>
+          </a:p>
+          <a:p>
+            <a:r>
+              <a:t>carreras más cortas, es que dentro de cada área se titulan antes.</a:t>
+            </a:r>
+          </a:p>
+        </p:txBody>
+      </p:sp>
+      <p:sp>
+        <p:nvSpPr>
+          <p:cNvPr id="4" name="Slide Number Placeholder 3"/>
+          <p:cNvSpPr>
+            <a:spLocks noGrp="1"/>
+          </p:cNvSpPr>
+          <p:nvPr>
+            <p:ph type="sldNum" idx="5" sz="quarter"/>
+          </p:nvPr>
+        </p:nvSpPr>
+        <p:spPr/>
+      </p:sp>
+    </p:spTree>
+  </p:cSld>
+  <p:clrMapOvr>
+    <a:masterClrMapping/>
+  </p:clrMapOvr>
+</p:notes>
+</file>
+
+<file path=ppt/notesSlides/notesSlide6.xml><?xml version="1.0" encoding="utf-8"?>
+<p:notes xmlns:a="http://schemas.openxmlformats.org/drawingml/2006/main" xmlns:p="http://schemas.openxmlformats.org/presentationml/2006/main" xmlns:r="http://schemas.openxmlformats.org/officeDocument/2006/relationships">
+  <p:cSld>
+    <p:spTree>
+      <p:nvGrpSpPr>
+        <p:cNvPr id="1" name=""/>
+        <p:cNvGrpSpPr/>
+        <p:nvPr/>
+      </p:nvGrpSpPr>
+      <p:grpSpPr>
+        <a:xfrm>
+          <a:off x="0" y="0"/>
+          <a:ext cx="0" cy="0"/>
+          <a:chOff x="0" y="0"/>
+          <a:chExt cx="0" cy="0"/>
+        </a:xfrm>
+      </p:grpSpPr>
+      <p:sp>
+        <p:nvSpPr>
+          <p:cNvPr id="2" name="Slide Image Placeholder 1"/>
+          <p:cNvSpPr>
+            <a:spLocks noGrp="1"/>
+          </p:cNvSpPr>
+          <p:nvPr>
+            <p:ph type="sldImg" idx="2"/>
+          </p:nvPr>
+        </p:nvSpPr>
+        <p:spPr/>
+      </p:sp>
+      <p:sp>
+        <p:nvSpPr>
+          <p:cNvPr id="3" name="Notes Placeholder 2"/>
+          <p:cNvSpPr>
+            <a:spLocks noGrp="1"/>
+          </p:cNvSpPr>
+          <p:nvPr>
+            <p:ph type="body" idx="3" sz="quarter"/>
+          </p:nvPr>
+        </p:nvSpPr>
+        <p:spPr/>
+        <p:txBody>
+          <a:bodyPr/>
+          <a:lstStyle/>
+          <a:p>
+            <a:r>
+              <a:t>[4:05 - 4:55 · 50 s]</a:t>
+            </a:r>
+          </a:p>
+          <a:p/>
+          <a:p>
+            <a:r>
+              <a:t>Este hallazgo no estaba en ninguna de las fases anteriores; apareció al mirar la serie</a:t>
+            </a:r>
+          </a:p>
+          <a:p>
+            <a:r>
+              <a:t>semestral en vez del promedio agregado.</a:t>
+            </a:r>
+          </a:p>
+          <a:p/>
+          <a:p>
+            <a:r>
+              <a:t>En 2020 se titularon unas 87 mil personas menos que en un año normal, y la sobreduración</a:t>
+            </a:r>
+          </a:p>
+          <a:p>
+            <a:r>
+              <a:t>media tocó su mínimo. En 2021 el volumen se recuperó y la sobreduración alcanzó su</a:t>
+            </a:r>
+          </a:p>
+          <a:p>
+            <a:r>
+              <a:t>máximo.</a:t>
+            </a:r>
+          </a:p>
+          <a:p/>
+          <a:p>
+            <a:r>
+              <a:t>La tentación es decir que 2020 fue un buen año. Pero no: las titulaciones se</a:t>
+            </a:r>
+          </a:p>
+          <a:p>
+            <a:r>
+              <a:t>POSTERGARON. Quienes debían egresar en 2020 lo hicieron en 2021, con uno o dos semestres</a:t>
+            </a:r>
+          </a:p>
+          <a:p>
+            <a:r>
+              <a:t>adicionales encima. El mínimo y el máximo son el mismo fenómeno visto en dos momentos, y</a:t>
+            </a:r>
+          </a:p>
+          <a:p>
+            <a:r>
+              <a:t>el mecanismo es de desplazamiento administrativo, no de deterioro académico.</a:t>
+            </a:r>
+          </a:p>
+        </p:txBody>
+      </p:sp>
+      <p:sp>
+        <p:nvSpPr>
+          <p:cNvPr id="4" name="Slide Number Placeholder 3"/>
+          <p:cNvSpPr>
+            <a:spLocks noGrp="1"/>
+          </p:cNvSpPr>
+          <p:nvPr>
+            <p:ph type="sldNum" idx="5" sz="quarter"/>
+          </p:nvPr>
+        </p:nvSpPr>
+        <p:spPr/>
+      </p:sp>
+    </p:spTree>
+  </p:cSld>
+  <p:clrMapOvr>
+    <a:masterClrMapping/>
+  </p:clrMapOvr>
+</p:notes>
+</file>
+
+<file path=ppt/notesSlides/notesSlide7.xml><?xml version="1.0" encoding="utf-8"?>
+<p:notes xmlns:a="http://schemas.openxmlformats.org/drawingml/2006/main" xmlns:p="http://schemas.openxmlformats.org/presentationml/2006/main" xmlns:r="http://schemas.openxmlformats.org/officeDocument/2006/relationships">
+  <p:cSld>
+    <p:spTree>
+      <p:nvGrpSpPr>
+        <p:cNvPr id="1" name=""/>
+        <p:cNvGrpSpPr/>
+        <p:nvPr/>
+      </p:nvGrpSpPr>
+      <p:grpSpPr>
+        <a:xfrm>
+          <a:off x="0" y="0"/>
+          <a:ext cx="0" cy="0"/>
+          <a:chOff x="0" y="0"/>
+          <a:chExt cx="0" cy="0"/>
+        </a:xfrm>
+      </p:grpSpPr>
+      <p:sp>
+        <p:nvSpPr>
+          <p:cNvPr id="2" name="Slide Image Placeholder 1"/>
+          <p:cNvSpPr>
+            <a:spLocks noGrp="1"/>
+          </p:cNvSpPr>
+          <p:nvPr>
+            <p:ph type="sldImg" idx="2"/>
+          </p:nvPr>
+        </p:nvSpPr>
+        <p:spPr/>
+      </p:sp>
+      <p:sp>
+        <p:nvSpPr>
+          <p:cNvPr id="3" name="Notes Placeholder 2"/>
+          <p:cNvSpPr>
+            <a:spLocks noGrp="1"/>
+          </p:cNvSpPr>
+          <p:nvPr>
+            <p:ph type="body" idx="3" sz="quarter"/>
+          </p:nvPr>
+        </p:nvSpPr>
+        <p:spPr/>
+        <p:txBody>
+          <a:bodyPr/>
+          <a:lstStyle/>
+          <a:p>
+            <a:r>
+              <a:t>[4:55 - 5:35 · 40 s]</a:t>
+            </a:r>
+          </a:p>
+          <a:p/>
+          <a:p>
+            <a:r>
+              <a:t>Y aquí una limitación que condiciona todo lo anterior, y que creo que es uno de los</a:t>
+            </a:r>
+          </a:p>
+          <a:p>
+            <a:r>
+              <a:t>resultados más valiosos del proyecto.</a:t>
+            </a:r>
+          </a:p>
+          <a:p/>
+          <a:p>
+            <a:r>
+              <a:t>Una base de titulados solo contiene a quien terminó. De las cohortes recientes solo se</a:t>
+            </a:r>
+          </a:p>
+          <a:p>
+            <a:r>
+              <a:t>han titulado los excepcionalmente rápidos, porque son los únicos que alcanzaron a</a:t>
+            </a:r>
+          </a:p>
+          <a:p>
+            <a:r>
+              <a:t>hacerlo. De las cohortes antiguas, en cambio, los que aparecen son los extremadamente</a:t>
+            </a:r>
+          </a:p>
+          <a:p>
+            <a:r>
+              <a:t>rezagados.</a:t>
+            </a:r>
+          </a:p>
+          <a:p/>
+          <a:p>
+            <a:r>
+              <a:t>Ninguna cohorte está completa, y lo están en direcciones opuestas. Por eso el descenso</a:t>
+            </a:r>
+          </a:p>
+          <a:p>
+            <a:r>
+              <a:t>de la serie desde 2024 no puede leerse como una mejora del sistema. Es una limitación de</a:t>
+            </a:r>
+          </a:p>
+          <a:p>
+            <a:r>
+              <a:t>la fuente, no del procesamiento, y declararla es parte del resultado.</a:t>
+            </a:r>
+          </a:p>
+        </p:txBody>
+      </p:sp>
+      <p:sp>
+        <p:nvSpPr>
+          <p:cNvPr id="4" name="Slide Number Placeholder 3"/>
+          <p:cNvSpPr>
+            <a:spLocks noGrp="1"/>
+          </p:cNvSpPr>
+          <p:nvPr>
+            <p:ph type="sldNum" idx="5" sz="quarter"/>
+          </p:nvPr>
+        </p:nvSpPr>
+        <p:spPr/>
+      </p:sp>
+    </p:spTree>
+  </p:cSld>
+  <p:clrMapOvr>
+    <a:masterClrMapping/>
+  </p:clrMapOvr>
+</p:notes>
+</file>
+
+<file path=ppt/notesSlides/notesSlide8.xml><?xml version="1.0" encoding="utf-8"?>
+<p:notes xmlns:a="http://schemas.openxmlformats.org/drawingml/2006/main" xmlns:p="http://schemas.openxmlformats.org/presentationml/2006/main" xmlns:r="http://schemas.openxmlformats.org/officeDocument/2006/relationships">
+  <p:cSld>
+    <p:spTree>
+      <p:nvGrpSpPr>
+        <p:cNvPr id="1" name=""/>
+        <p:cNvGrpSpPr/>
+        <p:nvPr/>
+      </p:nvGrpSpPr>
+      <p:grpSpPr>
+        <a:xfrm>
+          <a:off x="0" y="0"/>
+          <a:ext cx="0" cy="0"/>
+          <a:chOff x="0" y="0"/>
+          <a:chExt cx="0" cy="0"/>
+        </a:xfrm>
+      </p:grpSpPr>
+      <p:sp>
+        <p:nvSpPr>
+          <p:cNvPr id="2" name="Slide Image Placeholder 1"/>
+          <p:cNvSpPr>
+            <a:spLocks noGrp="1"/>
+          </p:cNvSpPr>
+          <p:nvPr>
+            <p:ph type="sldImg" idx="2"/>
+          </p:nvPr>
+        </p:nvSpPr>
+        <p:spPr/>
+      </p:sp>
+      <p:sp>
+        <p:nvSpPr>
+          <p:cNvPr id="3" name="Notes Placeholder 2"/>
+          <p:cNvSpPr>
+            <a:spLocks noGrp="1"/>
+          </p:cNvSpPr>
+          <p:nvPr>
+            <p:ph type="body" idx="3" sz="quarter"/>
+          </p:nvPr>
+        </p:nvSpPr>
+        <p:spPr/>
+        <p:txBody>
+          <a:bodyPr/>
+          <a:lstStyle/>
+          <a:p>
+            <a:r>
+              <a:t>[5:35 - 6:15 · 40 s]</a:t>
+            </a:r>
+          </a:p>
+          <a:p/>
+          <a:p>
+            <a:r>
+              <a:t>Sobre el trabajo técnico: el proyecto tiene 73 pruebas automatizadas que cubren casos</a:t>
+            </a:r>
+          </a:p>
+          <a:p>
+            <a:r>
+              <a:t>normales, límite y excepciones, y 9 reglas de coherencia del dominio, todas aprobadas.</a:t>
+            </a:r>
+          </a:p>
+          <a:p/>
+          <a:p>
+            <a:r>
+              <a:t>Los algoritmos se implementaron desde cero y se verificaron contra pandas, sorted y</a:t>
+            </a:r>
+          </a:p>
+          <a:p>
+            <a:r>
+              <a:t>NumPy ANTES de medir su tiempo: medir un algoritmo incorrecto no tiene sentido.</a:t>
+            </a:r>
+          </a:p>
+          <a:p/>
+          <a:p>
+            <a:r>
+              <a:t>Las curvas log-log confirmaron las cotas teóricas, pero también mostraron dónde la</a:t>
+            </a:r>
+          </a:p>
+          <a:p>
+            <a:r>
+              <a:t>teoría no basta: quickselect es orden n en comparaciones y sin embargo escala como n</a:t>
+            </a:r>
+          </a:p>
+          <a:p>
+            <a:r>
+              <a:t>elevado a 1,22, porque cada nivel de recursión asigna tres listas nuevas. La cota</a:t>
+            </a:r>
+          </a:p>
+          <a:p>
+            <a:r>
+              <a:t>describe el crecimiento, no la constante. Ese contraste fue uno de los aprendizajes</a:t>
+            </a:r>
+          </a:p>
+          <a:p>
+            <a:r>
+              <a:t>centrales del curso.</a:t>
+            </a:r>
+          </a:p>
+          <a:p/>
+          <a:p>
+            <a:r>
+              <a:t>SI EL VIDEO VA LARGO, recortar esta lámina a las dos primeras cifras y omitir el detalle</a:t>
+            </a:r>
+          </a:p>
+          <a:p>
+            <a:r>
+              <a:t>de quickselect: ahorra unos 20 segundos.</a:t>
+            </a:r>
+          </a:p>
+        </p:txBody>
+      </p:sp>
+      <p:sp>
+        <p:nvSpPr>
+          <p:cNvPr id="4" name="Slide Number Placeholder 3"/>
+          <p:cNvSpPr>
+            <a:spLocks noGrp="1"/>
+          </p:cNvSpPr>
+          <p:nvPr>
+            <p:ph type="sldNum" idx="5" sz="quarter"/>
+          </p:nvPr>
+        </p:nvSpPr>
+        <p:spPr/>
+      </p:sp>
+    </p:spTree>
+  </p:cSld>
+  <p:clrMapOvr>
+    <a:masterClrMapping/>
+  </p:clrMapOvr>
+</p:notes>
+</file>
+
+<file path=ppt/notesSlides/notesSlide9.xml><?xml version="1.0" encoding="utf-8"?>
+<p:notes xmlns:a="http://schemas.openxmlformats.org/drawingml/2006/main" xmlns:p="http://schemas.openxmlformats.org/presentationml/2006/main" xmlns:r="http://schemas.openxmlformats.org/officeDocument/2006/relationships">
+  <p:cSld>
+    <p:spTree>
+      <p:nvGrpSpPr>
+        <p:cNvPr id="1" name=""/>
+        <p:cNvGrpSpPr/>
+        <p:nvPr/>
+      </p:nvGrpSpPr>
+      <p:grpSpPr>
+        <a:xfrm>
+          <a:off x="0" y="0"/>
+          <a:ext cx="0" cy="0"/>
+          <a:chOff x="0" y="0"/>
+          <a:chExt cx="0" cy="0"/>
+        </a:xfrm>
+      </p:grpSpPr>
+      <p:sp>
+        <p:nvSpPr>
+          <p:cNvPr id="2" name="Slide Image Placeholder 1"/>
+          <p:cNvSpPr>
+            <a:spLocks noGrp="1"/>
+          </p:cNvSpPr>
+          <p:nvPr>
+            <p:ph type="sldImg" idx="2"/>
+          </p:nvPr>
+        </p:nvSpPr>
+        <p:spPr/>
+      </p:sp>
+      <p:sp>
+        <p:nvSpPr>
+          <p:cNvPr id="3" name="Notes Placeholder 2"/>
+          <p:cNvSpPr>
+            <a:spLocks noGrp="1"/>
+          </p:cNvSpPr>
+          <p:nvPr>
+            <p:ph type="body" idx="3" sz="quarter"/>
+          </p:nvPr>
+        </p:nvSpPr>
+        <p:spPr/>
+        <p:txBody>
+          <a:bodyPr/>
+          <a:lstStyle/>
+          <a:p>
+            <a:r>
+              <a:t>[6:15 - 6:55 · 40 s]</a:t>
+            </a:r>
+          </a:p>
+          <a:p/>
+          <a:p>
+            <a:r>
+              <a:t>En síntesis, cuatro conclusiones.</a:t>
+            </a:r>
+          </a:p>
+          <a:p/>
+          <a:p>
+            <a:r>
+              <a:t>El rezago es masivo y estructural, no aleatorio.</a:t>
+            </a:r>
+          </a:p>
+          <a:p/>
+          <a:p>
+            <a:r>
+              <a:t>La pandemia desplazó titulaciones en lugar de empeorarlas.</a:t>
+            </a:r>
+          </a:p>
+          <a:p/>
+          <a:p>
+            <a:r>
+              <a:t>Los registros administrativos no explican el caso individual: el R cuadrado es de 0 coma</a:t>
+            </a:r>
+          </a:p>
+          <a:p>
+            <a:r>
+              <a:t>085 y la clasificación no supera a predecir siempre la clase mayoritaria. Eso no es un</a:t>
+            </a:r>
+          </a:p>
+          <a:p>
+            <a:r>
+              <a:t>fracaso del modelo, es un resultado: el rezago depende de trayectorias personales que</a:t>
+            </a:r>
+          </a:p>
+          <a:p>
+            <a:r>
+              <a:t>esta fuente no registra.</a:t>
+            </a:r>
+          </a:p>
+          <a:p/>
+          <a:p>
+            <a:r>
+              <a:t>Y todo el proyecto es reproducible: cuatro comandos lo instalan y ejecutan, con 36</a:t>
+            </a:r>
+          </a:p>
+          <a:p>
+            <a:r>
+              <a:t>commits verificables y cada cifra rastreable hasta el archivo que la generó.</a:t>
+            </a:r>
+          </a:p>
+        </p:txBody>
+      </p:sp>
+      <p:sp>
+        <p:nvSpPr>
+          <p:cNvPr id="4" name="Slide Number Placeholder 3"/>
+          <p:cNvSpPr>
+            <a:spLocks noGrp="1"/>
+          </p:cNvSpPr>
+          <p:nvPr>
+            <p:ph type="sldNum" idx="5" sz="quarter"/>
+          </p:nvPr>
+        </p:nvSpPr>
+        <p:spPr/>
+      </p:sp>
+    </p:spTree>
+  </p:cSld>
+  <p:clrMapOvr>
+    <a:masterClrMapping/>
+  </p:clrMapOvr>
+</p:notes>
 </file>
 
 <file path=ppt/slideLayouts/slideLayout1.xml><?xml version="1.0" encoding="utf-8"?>

</xml_diff>

<commit_message>
docs(f4): alinea informe, figuras y presentacion con el apunte de la fase
- Informe: objetivos analiticos con su figura asignada y tabla de
  correspondencia; resultados reorganizados en torno a las tres figuras,
  cada una con sus cuatro enunciados de lectura; estratificacion de la
  brecha de genero; apartado de cortes descartados y del relato.
- Figuras renombradas (f4_fig1..fig4) con titulo-enunciado y color con
  funcion; las antiguas se eliminan del repositorio.
- Presentacion: titulos de lamina que enuncian el hallazgo y figuras
  nuevas; guion regenerado desde la misma fuente.
</commit_message>
<xml_diff>
--- a/informe/Presentacion_Fase4_Sebastian_Antunez.pptx
+++ b/informe/Presentacion_Fase4_Sebastian_Antunez.pptx
@@ -5473,7 +5473,7 @@
                 <a:ea typeface="Cambria" panose="02040503050406030204" pitchFamily="18" charset="0"/>
                 <a:cs typeface="Calibri Light" panose="020F0302020204030204" pitchFamily="34" charset="0"/>
               </a:rPr>
-              <a:t>EL RESULTADO PRINCIPAL</a:t>
+              <a:t>CUATRO DE CADA CINCO EGRESAN FUERA DE PLAZO</a:t>
             </a:r>
           </a:p>
         </p:txBody>
@@ -5880,7 +5880,7 @@
       </p:sp>
       <p:pic>
         <p:nvPicPr>
-          <p:cNvPr id="23" name="Picture 22" descr="f4_distribucion_sobreduracion.png"/>
+          <p:cNvPr id="23" name="Picture 22" descr="f4_fig1_magnitud.png"/>
           <p:cNvPicPr>
             <a:picLocks noChangeAspect="1"/>
           </p:cNvPicPr>
@@ -5894,8 +5894,8 @@
         </p:blipFill>
         <p:spPr>
           <a:xfrm>
-            <a:off x="2819524" y="3154680"/>
-            <a:ext cx="6552952" cy="2697480"/>
+            <a:off x="3710860" y="3154680"/>
+            <a:ext cx="4770280" cy="2697480"/>
           </a:xfrm>
           <a:prstGeom prst="rect">
             <a:avLst/>
@@ -6242,14 +6242,14 @@
                 <a:ea typeface="Cambria" panose="02040503050406030204" pitchFamily="18" charset="0"/>
                 <a:cs typeface="Calibri Light" panose="020F0302020204030204" pitchFamily="34" charset="0"/>
               </a:rPr>
-              <a:t>EL REZAGO NO ES HOMOGÉNEO</a:t>
+              <a:t>DERECHO TRIPLICA A EDUCACIÓN</a:t>
             </a:r>
           </a:p>
         </p:txBody>
       </p:sp>
       <p:pic>
         <p:nvPicPr>
-          <p:cNvPr id="15" name="Picture 14" descr="f4_factores_sobreduracion.png"/>
+          <p:cNvPr id="15" name="Picture 14" descr="f4_fig2_factores.png"/>
           <p:cNvPicPr>
             <a:picLocks noChangeAspect="1"/>
           </p:cNvPicPr>
@@ -6263,8 +6263,8 @@
         </p:blipFill>
         <p:spPr>
           <a:xfrm>
-            <a:off x="2134259" y="1645920"/>
-            <a:ext cx="7923481" cy="2880360"/>
+            <a:off x="3648968" y="1645920"/>
+            <a:ext cx="4894063" cy="2880360"/>
           </a:xfrm>
           <a:prstGeom prst="rect">
             <a:avLst/>
@@ -6307,7 +6307,7 @@
                   <a:srgbClr val="3B3B3B"/>
                 </a:solidFill>
               </a:rPr>
-              <a:t>Derecho triplica a Educación:</a:t>
+              <a:t>Casi cuatro semestres separan los</a:t>
             </a:r>
           </a:p>
           <a:p>
@@ -6325,7 +6325,7 @@
                   <a:srgbClr val="3B3B3B"/>
                 </a:solidFill>
               </a:rPr>
-              <a:t>5,77 frente a 1,93 semestres</a:t>
+              <a:t>extremos del ranking de áreas</a:t>
             </a:r>
           </a:p>
         </p:txBody>
@@ -6788,14 +6788,14 @@
                 <a:ea typeface="Cambria" panose="02040503050406030204" pitchFamily="18" charset="0"/>
                 <a:cs typeface="Calibri Light" panose="020F0302020204030204" pitchFamily="34" charset="0"/>
               </a:rPr>
-              <a:t>LA PANDEMIA DESPLAZÓ TITULACIONES</a:t>
+              <a:t>LA PANDEMIA DESPLAZÓ TITULACIONES, NO LAS EMPEORÓ</a:t>
             </a:r>
           </a:p>
         </p:txBody>
       </p:sp>
       <p:pic>
         <p:nvPicPr>
-          <p:cNvPr id="15" name="Picture 14" descr="f4_serie_temporal.png"/>
+          <p:cNvPr id="15" name="Picture 14" descr="f4_fig3_evolucion.png"/>
           <p:cNvPicPr>
             <a:picLocks noChangeAspect="1"/>
           </p:cNvPicPr>
@@ -6809,8 +6809,8 @@
         </p:blipFill>
         <p:spPr>
           <a:xfrm>
-            <a:off x="2854238" y="1600200"/>
-            <a:ext cx="6483524" cy="3063240"/>
+            <a:off x="3199283" y="1600200"/>
+            <a:ext cx="5793434" cy="3063240"/>
           </a:xfrm>
           <a:prstGeom prst="rect">
             <a:avLst/>
@@ -7216,14 +7216,14 @@
                 <a:ea typeface="Cambria" panose="02040503050406030204" pitchFamily="18" charset="0"/>
                 <a:cs typeface="Calibri Light" panose="020F0302020204030204" pitchFamily="34" charset="0"/>
               </a:rPr>
-              <a:t>UNA LIMITACIÓN QUE CONDICIONA TODO</a:t>
+              <a:t>NINGUNA COHORTE ESTÁ COMPLETA</a:t>
             </a:r>
           </a:p>
         </p:txBody>
       </p:sp>
       <p:pic>
         <p:nvPicPr>
-          <p:cNvPr id="15" name="Picture 14" descr="f4_truncamiento_cohortes.png"/>
+          <p:cNvPr id="15" name="Picture 14" descr="f4_fig4_truncamiento.png"/>
           <p:cNvPicPr>
             <a:picLocks noChangeAspect="1"/>
           </p:cNvPicPr>
@@ -7237,8 +7237,8 @@
         </p:blipFill>
         <p:spPr>
           <a:xfrm>
-            <a:off x="2400910" y="1600200"/>
-            <a:ext cx="7390180" cy="2880360"/>
+            <a:off x="3401347" y="1600200"/>
+            <a:ext cx="5389305" cy="2880360"/>
           </a:xfrm>
           <a:prstGeom prst="rect">
             <a:avLst/>

</xml_diff>

<commit_message>
Actualiza presentación de fase 4
</commit_message>
<xml_diff>
--- a/informe/Presentacion_Fase4_Sebastian_Antunez.pptx
+++ b/informe/Presentacion_Fase4_Sebastian_Antunez.pptx
@@ -521,7 +521,260 @@
           <a:bodyPr/>
           <a:lstStyle/>
           <a:p>
+            <a:r>
+              <a:t>Buenos </a:t>
+            </a:r>
+            <a:r>
+              <a:rPr dirty="0"/>
+              <a:t>días. Mi </a:t>
+            </a:r>
+            <a:r>
+              <a:rPr dirty="0" err="1"/>
+              <a:t>nombre</a:t>
+            </a:r>
+            <a:r>
+              <a:rPr dirty="0"/>
+              <a:t> es Sebastian Antunez y </a:t>
+            </a:r>
+            <a:r>
+              <a:rPr dirty="0" err="1"/>
+              <a:t>voy</a:t>
+            </a:r>
+            <a:r>
+              <a:rPr dirty="0"/>
+              <a:t> a </a:t>
+            </a:r>
+            <a:r>
+              <a:rPr dirty="0" err="1"/>
+              <a:t>presentar</a:t>
+            </a:r>
+            <a:r>
+              <a:rPr dirty="0"/>
+              <a:t> </a:t>
+            </a:r>
+            <a:r>
+              <a:rPr dirty="0" err="1"/>
+              <a:t>el</a:t>
+            </a:r>
+            <a:r>
+              <a:rPr dirty="0"/>
+              <a:t> </a:t>
+            </a:r>
+            <a:r>
+              <a:rPr dirty="0" err="1"/>
+              <a:t>proyecto</a:t>
+            </a:r>
+            <a:r>
+              <a:rPr dirty="0"/>
+              <a:t> final del</a:t>
+            </a:r>
+          </a:p>
+          <a:p>
+            <a:r>
+              <a:rPr dirty="0" err="1"/>
+              <a:t>curso</a:t>
+            </a:r>
+            <a:r>
+              <a:rPr dirty="0"/>
+              <a:t> </a:t>
+            </a:r>
+            <a:r>
+              <a:rPr dirty="0" err="1"/>
+              <a:t>Programación</a:t>
+            </a:r>
+            <a:r>
+              <a:rPr dirty="0"/>
+              <a:t> para la </a:t>
+            </a:r>
+            <a:r>
+              <a:rPr dirty="0" err="1"/>
+              <a:t>Ciencia</a:t>
+            </a:r>
+            <a:r>
+              <a:rPr dirty="0"/>
+              <a:t> de Datos: un </a:t>
+            </a:r>
+            <a:r>
+              <a:rPr dirty="0" err="1"/>
+              <a:t>análisis</a:t>
+            </a:r>
+            <a:r>
+              <a:rPr dirty="0"/>
+              <a:t> </a:t>
+            </a:r>
+            <a:r>
+              <a:rPr dirty="0" err="1"/>
+              <a:t>sobre</a:t>
+            </a:r>
+            <a:r>
+              <a:rPr dirty="0"/>
+              <a:t> la </a:t>
+            </a:r>
+            <a:r>
+              <a:rPr dirty="0" err="1"/>
+              <a:t>sobreduración</a:t>
+            </a:r>
+            <a:r>
+              <a:rPr dirty="0"/>
+              <a:t> </a:t>
+            </a:r>
+            <a:r>
+              <a:rPr dirty="0" err="1"/>
+              <a:t>en</a:t>
+            </a:r>
+            <a:r>
+              <a:rPr dirty="0"/>
+              <a:t> la</a:t>
+            </a:r>
+          </a:p>
+          <a:p>
+            <a:r>
+              <a:rPr dirty="0" err="1"/>
+              <a:t>titulación</a:t>
+            </a:r>
+            <a:r>
+              <a:rPr dirty="0"/>
+              <a:t> de la </a:t>
+            </a:r>
+            <a:r>
+              <a:rPr dirty="0" err="1"/>
+              <a:t>educación</a:t>
+            </a:r>
+            <a:r>
+              <a:rPr dirty="0"/>
+              <a:t> superior </a:t>
+            </a:r>
+            <a:r>
+              <a:rPr dirty="0" err="1"/>
+              <a:t>chilena</a:t>
+            </a:r>
+            <a:r>
+              <a:rPr dirty="0"/>
+              <a:t>, </a:t>
+            </a:r>
+            <a:r>
+              <a:rPr dirty="0" err="1"/>
+              <a:t>construido</a:t>
+            </a:r>
+            <a:r>
+              <a:rPr dirty="0"/>
+              <a:t> </a:t>
+            </a:r>
+            <a:r>
+              <a:rPr dirty="0" err="1"/>
+              <a:t>sobre</a:t>
+            </a:r>
+            <a:r>
+              <a:rPr dirty="0"/>
+              <a:t> 1.246.760 </a:t>
+            </a:r>
+            <a:r>
+              <a:rPr dirty="0" err="1"/>
+              <a:t>procesos</a:t>
+            </a:r>
+            <a:r>
+              <a:rPr dirty="0"/>
+              <a:t> de</a:t>
+            </a:r>
+          </a:p>
+          <a:p>
+            <a:r>
+              <a:rPr dirty="0" err="1"/>
+              <a:t>titulación</a:t>
+            </a:r>
+            <a:r>
+              <a:rPr dirty="0"/>
+              <a:t> </a:t>
+            </a:r>
+            <a:r>
+              <a:rPr dirty="0" err="1"/>
+              <a:t>reales</a:t>
+            </a:r>
+            <a:r>
+              <a:rPr dirty="0"/>
+              <a:t> entre 2020 y 2025.</a:t>
+            </a:r>
+          </a:p>
+          <a:p>
             <a:endParaRPr dirty="0"/>
+          </a:p>
+          <a:p>
+            <a:r>
+              <a:rPr dirty="0"/>
+              <a:t>RECORDAR: </a:t>
+            </a:r>
+            <a:r>
+              <a:rPr dirty="0" err="1"/>
+              <a:t>hablar</a:t>
+            </a:r>
+            <a:r>
+              <a:rPr dirty="0"/>
+              <a:t> </a:t>
+            </a:r>
+            <a:r>
+              <a:rPr dirty="0" err="1"/>
+              <a:t>más</a:t>
+            </a:r>
+            <a:r>
+              <a:rPr dirty="0"/>
+              <a:t> lento de lo que </a:t>
+            </a:r>
+            <a:r>
+              <a:rPr dirty="0" err="1"/>
+              <a:t>parece</a:t>
+            </a:r>
+            <a:r>
+              <a:rPr dirty="0"/>
+              <a:t> natural; </a:t>
+            </a:r>
+            <a:r>
+              <a:rPr dirty="0" err="1"/>
+              <a:t>en</a:t>
+            </a:r>
+            <a:r>
+              <a:rPr dirty="0"/>
+              <a:t> </a:t>
+            </a:r>
+            <a:r>
+              <a:rPr dirty="0" err="1"/>
+              <a:t>grabación</a:t>
+            </a:r>
+            <a:r>
+              <a:rPr dirty="0"/>
+              <a:t> </a:t>
+            </a:r>
+            <a:r>
+              <a:rPr dirty="0" err="1"/>
+              <a:t>siempre</a:t>
+            </a:r>
+            <a:r>
+              <a:rPr dirty="0"/>
+              <a:t> </a:t>
+            </a:r>
+            <a:r>
+              <a:rPr dirty="0" err="1"/>
+              <a:t>suena</a:t>
+            </a:r>
+            <a:r>
+              <a:rPr dirty="0"/>
+              <a:t> </a:t>
+            </a:r>
+            <a:r>
+              <a:rPr dirty="0" err="1"/>
+              <a:t>más</a:t>
+            </a:r>
+            <a:r>
+              <a:rPr dirty="0"/>
+              <a:t> </a:t>
+            </a:r>
+            <a:r>
+              <a:rPr dirty="0" err="1"/>
+              <a:t>rápido</a:t>
+            </a:r>
+            <a:r>
+              <a:rPr dirty="0"/>
+              <a:t>.</a:t>
+            </a:r>
           </a:p>
         </p:txBody>
       </p:sp>
@@ -589,7 +842,35 @@
           <a:bodyPr/>
           <a:lstStyle/>
           <a:p>
-            <a:endParaRPr dirty="0"/>
+            <a:r>
+              <a:t>[6:55 - 7:10 · 15 s]</a:t>
+            </a:r>
+          </a:p>
+          <a:p>
+            <a:endParaRPr/>
+          </a:p>
+          <a:p>
+            <a:r>
+              <a:t>Lo que queda para seguir: incorporar la base de matrícula para ver la deserción, que hoy</a:t>
+            </a:r>
+          </a:p>
+          <a:p>
+            <a:r>
+              <a:t>es invisible; usar modelos de supervivencia, que son los adecuados para datos</a:t>
+            </a:r>
+          </a:p>
+          <a:p>
+            <a:r>
+              <a:t>censurados; y ampliar las variables hacia la trayectoria individual.</a:t>
+            </a:r>
+          </a:p>
+          <a:p>
+            <a:endParaRPr/>
+          </a:p>
+          <a:p>
+            <a:r>
+              <a:t>El repositorio completo está disponible en GitHub. Muchas gracias.</a:t>
+            </a:r>
           </a:p>
         </p:txBody>
       </p:sp>
@@ -657,7 +938,66 @@
           <a:bodyPr/>
           <a:lstStyle/>
           <a:p>
-            <a:endParaRPr dirty="0"/>
+            <a:r>
+              <a:t>[0:20 - 1:10 · 50 s]</a:t>
+            </a:r>
+          </a:p>
+          <a:p>
+            <a:endParaRPr/>
+          </a:p>
+          <a:p>
+            <a:r>
+              <a:t>Cada carrera en Chile declara una duración teórica. Sobre esa cifra se calculan la</a:t>
+            </a:r>
+          </a:p>
+          <a:p>
+            <a:r>
+              <a:t>duración de las becas y los créditos estatales.</a:t>
+            </a:r>
+          </a:p>
+          <a:p>
+            <a:endParaRPr/>
+          </a:p>
+          <a:p>
+            <a:r>
+              <a:t>Lo que el sistema no publica es cuánto se tarda en realidad. Y aquí está el punto de</a:t>
+            </a:r>
+          </a:p>
+          <a:p>
+            <a:r>
+              <a:t>partida: al revisar el esquema oficial del SIES descubrí que las columnas que parecían</a:t>
+            </a:r>
+          </a:p>
+          <a:p>
+            <a:r>
+              <a:t>tener la respuesta NO registran lo que el estudiante tardó, sino lo que el plan declara.</a:t>
+            </a:r>
+          </a:p>
+          <a:p>
+            <a:r>
+              <a:t>Son un atributo de la carrera, no de la persona.</a:t>
+            </a:r>
+          </a:p>
+          <a:p>
+            <a:endParaRPr/>
+          </a:p>
+          <a:p>
+            <a:r>
+              <a:t>Así que la pregunta fue: se puede reconstruir la duración real desde los registros</a:t>
+            </a:r>
+          </a:p>
+          <a:p>
+            <a:r>
+              <a:t>administrativos, y caracterizar el rezago con esa variable derivada.</a:t>
+            </a:r>
+          </a:p>
+          <a:p>
+            <a:endParaRPr/>
+          </a:p>
+          <a:p>
+            <a:r>
+              <a:t>PAUSA de medio segundo antes de avanzar: es la bisagra del relato.</a:t>
+            </a:r>
           </a:p>
         </p:txBody>
       </p:sp>
@@ -725,7 +1065,711 @@
           <a:bodyPr/>
           <a:lstStyle/>
           <a:p>
+            <a:r>
+              <a:rPr dirty="0"/>
+              <a:t>El </a:t>
+            </a:r>
+            <a:r>
+              <a:rPr dirty="0" err="1"/>
+              <a:t>proyecto</a:t>
+            </a:r>
+            <a:r>
+              <a:rPr dirty="0"/>
+              <a:t> se </a:t>
+            </a:r>
+            <a:r>
+              <a:rPr dirty="0" err="1"/>
+              <a:t>desarrolló</a:t>
+            </a:r>
+            <a:r>
+              <a:rPr dirty="0"/>
+              <a:t> </a:t>
+            </a:r>
+            <a:r>
+              <a:rPr dirty="0" err="1"/>
+              <a:t>en</a:t>
+            </a:r>
+            <a:r>
+              <a:rPr dirty="0"/>
+              <a:t> cuatro </a:t>
+            </a:r>
+            <a:r>
+              <a:rPr dirty="0" err="1"/>
+              <a:t>fases</a:t>
+            </a:r>
+            <a:r>
+              <a:rPr dirty="0"/>
+              <a:t>. La </a:t>
+            </a:r>
+            <a:r>
+              <a:rPr dirty="0" err="1"/>
+              <a:t>primera</a:t>
+            </a:r>
+            <a:r>
+              <a:rPr dirty="0"/>
+              <a:t> </a:t>
+            </a:r>
+            <a:r>
+              <a:rPr dirty="0" err="1"/>
+              <a:t>definió</a:t>
+            </a:r>
+            <a:r>
+              <a:rPr dirty="0"/>
+              <a:t> </a:t>
+            </a:r>
+            <a:r>
+              <a:rPr dirty="0" err="1"/>
+              <a:t>el</a:t>
+            </a:r>
+            <a:r>
+              <a:rPr dirty="0"/>
+              <a:t> </a:t>
+            </a:r>
+            <a:r>
+              <a:rPr dirty="0" err="1"/>
+              <a:t>problema</a:t>
+            </a:r>
+            <a:r>
+              <a:rPr dirty="0"/>
+              <a:t> y </a:t>
+            </a:r>
+            <a:r>
+              <a:rPr dirty="0" err="1"/>
+              <a:t>levantó</a:t>
+            </a:r>
+            <a:r>
+              <a:rPr dirty="0"/>
+              <a:t> </a:t>
+            </a:r>
+            <a:r>
+              <a:rPr dirty="0" err="1"/>
+              <a:t>el</a:t>
+            </a:r>
             <a:endParaRPr dirty="0"/>
+          </a:p>
+          <a:p>
+            <a:r>
+              <a:rPr dirty="0" err="1"/>
+              <a:t>entorno</a:t>
+            </a:r>
+            <a:r>
+              <a:rPr dirty="0"/>
+              <a:t> reproducible. La </a:t>
+            </a:r>
+            <a:r>
+              <a:rPr dirty="0" err="1"/>
+              <a:t>segunda</a:t>
+            </a:r>
+            <a:r>
+              <a:rPr dirty="0"/>
+              <a:t> </a:t>
+            </a:r>
+            <a:r>
+              <a:rPr dirty="0" err="1"/>
+              <a:t>construyó</a:t>
+            </a:r>
+            <a:r>
+              <a:rPr dirty="0"/>
+              <a:t> </a:t>
+            </a:r>
+            <a:r>
+              <a:rPr dirty="0" err="1"/>
+              <a:t>el</a:t>
+            </a:r>
+            <a:r>
+              <a:rPr dirty="0"/>
+              <a:t> pipeline que </a:t>
+            </a:r>
+            <a:r>
+              <a:rPr dirty="0" err="1"/>
+              <a:t>convierte</a:t>
+            </a:r>
+            <a:r>
+              <a:rPr dirty="0"/>
+              <a:t> 955 megabytes de</a:t>
+            </a:r>
+          </a:p>
+          <a:p>
+            <a:r>
+              <a:rPr dirty="0" err="1"/>
+              <a:t>archivos</a:t>
+            </a:r>
+            <a:r>
+              <a:rPr dirty="0"/>
+              <a:t> crudos </a:t>
+            </a:r>
+            <a:r>
+              <a:rPr dirty="0" err="1"/>
+              <a:t>en</a:t>
+            </a:r>
+            <a:r>
+              <a:rPr dirty="0"/>
+              <a:t> un conjunto </a:t>
+            </a:r>
+            <a:r>
+              <a:rPr dirty="0" err="1"/>
+              <a:t>analítico</a:t>
+            </a:r>
+            <a:r>
+              <a:rPr dirty="0"/>
+              <a:t> </a:t>
+            </a:r>
+            <a:r>
+              <a:rPr dirty="0" err="1"/>
+              <a:t>validado</a:t>
+            </a:r>
+            <a:r>
+              <a:rPr dirty="0"/>
+              <a:t>. La </a:t>
+            </a:r>
+            <a:r>
+              <a:rPr dirty="0" err="1"/>
+              <a:t>tercera</a:t>
+            </a:r>
+            <a:r>
+              <a:rPr dirty="0"/>
+              <a:t> </a:t>
+            </a:r>
+            <a:r>
+              <a:rPr dirty="0" err="1"/>
+              <a:t>implementó</a:t>
+            </a:r>
+            <a:r>
+              <a:rPr dirty="0"/>
+              <a:t> </a:t>
+            </a:r>
+            <a:r>
+              <a:rPr dirty="0" err="1"/>
+              <a:t>el</a:t>
+            </a:r>
+            <a:r>
+              <a:rPr dirty="0"/>
+              <a:t> </a:t>
+            </a:r>
+            <a:r>
+              <a:rPr dirty="0" err="1"/>
+              <a:t>núcleo</a:t>
+            </a:r>
+            <a:endParaRPr dirty="0"/>
+          </a:p>
+          <a:p>
+            <a:r>
+              <a:rPr dirty="0" err="1"/>
+              <a:t>algorítmico</a:t>
+            </a:r>
+            <a:r>
+              <a:rPr dirty="0"/>
+              <a:t> </a:t>
+            </a:r>
+            <a:r>
+              <a:rPr dirty="0" err="1"/>
+              <a:t>desde</a:t>
+            </a:r>
+            <a:r>
+              <a:rPr dirty="0"/>
+              <a:t> </a:t>
+            </a:r>
+            <a:r>
+              <a:rPr dirty="0" err="1"/>
+              <a:t>primeros</a:t>
+            </a:r>
+            <a:r>
+              <a:rPr dirty="0"/>
+              <a:t> </a:t>
+            </a:r>
+            <a:r>
+              <a:rPr dirty="0" err="1"/>
+              <a:t>principios</a:t>
+            </a:r>
+            <a:r>
+              <a:rPr dirty="0"/>
+              <a:t>, con </a:t>
+            </a:r>
+            <a:r>
+              <a:rPr dirty="0" err="1"/>
+              <a:t>medición</a:t>
+            </a:r>
+            <a:r>
+              <a:rPr dirty="0"/>
+              <a:t> formal de </a:t>
+            </a:r>
+            <a:r>
+              <a:rPr dirty="0" err="1"/>
+              <a:t>complejidad</a:t>
+            </a:r>
+            <a:r>
+              <a:rPr dirty="0"/>
+              <a:t> y un </a:t>
+            </a:r>
+            <a:r>
+              <a:rPr dirty="0" err="1"/>
+              <a:t>modelo</a:t>
+            </a:r>
+            <a:r>
+              <a:rPr dirty="0"/>
+              <a:t> de</a:t>
+            </a:r>
+          </a:p>
+          <a:p>
+            <a:r>
+              <a:rPr dirty="0" err="1"/>
+              <a:t>dominio</a:t>
+            </a:r>
+            <a:r>
+              <a:rPr dirty="0"/>
+              <a:t> </a:t>
+            </a:r>
+            <a:r>
+              <a:rPr dirty="0" err="1"/>
+              <a:t>orientado</a:t>
+            </a:r>
+            <a:r>
+              <a:rPr dirty="0"/>
+              <a:t> a </a:t>
+            </a:r>
+            <a:r>
+              <a:rPr dirty="0" err="1"/>
+              <a:t>objetos</a:t>
+            </a:r>
+            <a:r>
+              <a:rPr dirty="0"/>
+              <a:t>. Y la </a:t>
+            </a:r>
+            <a:r>
+              <a:rPr dirty="0" err="1"/>
+              <a:t>cuarta</a:t>
+            </a:r>
+            <a:r>
+              <a:rPr dirty="0"/>
+              <a:t>, que es la que </a:t>
+            </a:r>
+            <a:r>
+              <a:rPr dirty="0" err="1"/>
+              <a:t>presento</a:t>
+            </a:r>
+            <a:r>
+              <a:rPr dirty="0"/>
+              <a:t>, </a:t>
+            </a:r>
+            <a:r>
+              <a:rPr dirty="0" err="1"/>
+              <a:t>ejecuta</a:t>
+            </a:r>
+            <a:r>
+              <a:rPr dirty="0"/>
+              <a:t> </a:t>
+            </a:r>
+            <a:r>
+              <a:rPr dirty="0" err="1"/>
+              <a:t>todo</a:t>
+            </a:r>
+            <a:r>
+              <a:rPr dirty="0"/>
+              <a:t> </a:t>
+            </a:r>
+            <a:r>
+              <a:rPr dirty="0" err="1"/>
+              <a:t>eso</a:t>
+            </a:r>
+            <a:r>
+              <a:rPr dirty="0"/>
+              <a:t> de</a:t>
+            </a:r>
+          </a:p>
+          <a:p>
+            <a:r>
+              <a:rPr dirty="0" err="1"/>
+              <a:t>extremo</a:t>
+            </a:r>
+            <a:r>
+              <a:rPr dirty="0"/>
+              <a:t> a </a:t>
+            </a:r>
+            <a:r>
+              <a:rPr dirty="0" err="1"/>
+              <a:t>extremo</a:t>
+            </a:r>
+            <a:r>
+              <a:rPr dirty="0"/>
+              <a:t>.</a:t>
+            </a:r>
+          </a:p>
+          <a:p>
+            <a:endParaRPr dirty="0"/>
+          </a:p>
+          <a:p>
+            <a:r>
+              <a:rPr dirty="0"/>
+              <a:t>La </a:t>
+            </a:r>
+            <a:r>
+              <a:rPr dirty="0" err="1"/>
+              <a:t>transformación</a:t>
+            </a:r>
+            <a:r>
+              <a:rPr dirty="0"/>
+              <a:t> central </a:t>
+            </a:r>
+            <a:r>
+              <a:rPr dirty="0" err="1"/>
+              <a:t>está</a:t>
+            </a:r>
+            <a:r>
+              <a:rPr dirty="0"/>
+              <a:t> </a:t>
+            </a:r>
+            <a:r>
+              <a:rPr dirty="0" err="1"/>
+              <a:t>abajo</a:t>
+            </a:r>
+            <a:r>
+              <a:rPr dirty="0"/>
+              <a:t>: la </a:t>
+            </a:r>
+            <a:r>
+              <a:rPr dirty="0" err="1"/>
+              <a:t>duración</a:t>
+            </a:r>
+            <a:r>
+              <a:rPr dirty="0"/>
+              <a:t> real se </a:t>
+            </a:r>
+            <a:r>
+              <a:rPr dirty="0" err="1"/>
+              <a:t>deriva</a:t>
+            </a:r>
+            <a:r>
+              <a:rPr dirty="0"/>
+              <a:t> del </a:t>
+            </a:r>
+            <a:r>
+              <a:rPr dirty="0" err="1"/>
+              <a:t>año</a:t>
+            </a:r>
+            <a:r>
+              <a:rPr dirty="0"/>
+              <a:t> y </a:t>
+            </a:r>
+            <a:r>
+              <a:rPr dirty="0" err="1"/>
+              <a:t>semestre</a:t>
+            </a:r>
+            <a:r>
+              <a:rPr dirty="0"/>
+              <a:t> de</a:t>
+            </a:r>
+          </a:p>
+          <a:p>
+            <a:r>
+              <a:rPr dirty="0" err="1"/>
+              <a:t>ingreso</a:t>
+            </a:r>
+            <a:r>
+              <a:rPr dirty="0"/>
+              <a:t> y de </a:t>
+            </a:r>
+            <a:r>
+              <a:rPr dirty="0" err="1"/>
+              <a:t>titulación</a:t>
+            </a:r>
+            <a:r>
+              <a:rPr dirty="0"/>
+              <a:t>. El "</a:t>
+            </a:r>
+            <a:r>
+              <a:rPr dirty="0" err="1"/>
+              <a:t>más</a:t>
+            </a:r>
+            <a:r>
+              <a:rPr dirty="0"/>
+              <a:t> uno" no es </a:t>
+            </a:r>
+            <a:r>
+              <a:rPr dirty="0" err="1"/>
+              <a:t>arbitrario</a:t>
+            </a:r>
+            <a:r>
+              <a:rPr dirty="0"/>
+              <a:t>: </a:t>
+            </a:r>
+            <a:r>
+              <a:rPr dirty="0" err="1"/>
+              <a:t>quien</a:t>
+            </a:r>
+            <a:r>
+              <a:rPr dirty="0"/>
+              <a:t> </a:t>
+            </a:r>
+            <a:r>
+              <a:rPr dirty="0" err="1"/>
+              <a:t>ingresa</a:t>
+            </a:r>
+            <a:r>
+              <a:rPr dirty="0"/>
+              <a:t> y se </a:t>
+            </a:r>
+            <a:r>
+              <a:rPr dirty="0" err="1"/>
+              <a:t>titula</a:t>
+            </a:r>
+            <a:r>
+              <a:rPr dirty="0"/>
+              <a:t> </a:t>
+            </a:r>
+            <a:r>
+              <a:rPr dirty="0" err="1"/>
+              <a:t>en</a:t>
+            </a:r>
+            <a:r>
+              <a:rPr dirty="0"/>
+              <a:t> </a:t>
+            </a:r>
+            <a:r>
+              <a:rPr dirty="0" err="1"/>
+              <a:t>el</a:t>
+            </a:r>
+            <a:endParaRPr dirty="0"/>
+          </a:p>
+          <a:p>
+            <a:r>
+              <a:rPr dirty="0" err="1"/>
+              <a:t>mismo</a:t>
+            </a:r>
+            <a:r>
+              <a:rPr dirty="0"/>
+              <a:t> </a:t>
+            </a:r>
+            <a:r>
+              <a:rPr dirty="0" err="1"/>
+              <a:t>semestre</a:t>
+            </a:r>
+            <a:r>
+              <a:rPr dirty="0"/>
+              <a:t> </a:t>
+            </a:r>
+            <a:r>
+              <a:rPr dirty="0" err="1"/>
+              <a:t>cursó</a:t>
+            </a:r>
+            <a:r>
+              <a:rPr dirty="0"/>
+              <a:t> un </a:t>
+            </a:r>
+            <a:r>
+              <a:rPr dirty="0" err="1"/>
+              <a:t>semestre</a:t>
+            </a:r>
+            <a:r>
+              <a:rPr dirty="0"/>
+              <a:t>, no cero. Esa </a:t>
+            </a:r>
+            <a:r>
+              <a:rPr dirty="0" err="1"/>
+              <a:t>coherencia</a:t>
+            </a:r>
+            <a:r>
+              <a:rPr dirty="0"/>
+              <a:t> </a:t>
+            </a:r>
+            <a:r>
+              <a:rPr dirty="0" err="1"/>
+              <a:t>aritmética</a:t>
+            </a:r>
+            <a:r>
+              <a:rPr dirty="0"/>
+              <a:t> se </a:t>
+            </a:r>
+            <a:r>
+              <a:rPr dirty="0" err="1"/>
+              <a:t>verifica</a:t>
+            </a:r>
+            <a:r>
+              <a:rPr dirty="0"/>
+              <a:t> </a:t>
+            </a:r>
+            <a:r>
+              <a:rPr dirty="0" err="1"/>
+              <a:t>como</a:t>
+            </a:r>
+            <a:endParaRPr dirty="0"/>
+          </a:p>
+          <a:p>
+            <a:r>
+              <a:rPr dirty="0" err="1"/>
+              <a:t>regla</a:t>
+            </a:r>
+            <a:r>
+              <a:rPr dirty="0"/>
+              <a:t> de </a:t>
+            </a:r>
+            <a:r>
+              <a:rPr dirty="0" err="1"/>
+              <a:t>validación</a:t>
+            </a:r>
+            <a:r>
+              <a:rPr dirty="0"/>
+              <a:t> </a:t>
+            </a:r>
+            <a:r>
+              <a:rPr dirty="0" err="1"/>
+              <a:t>sobre</a:t>
+            </a:r>
+            <a:r>
+              <a:rPr dirty="0"/>
+              <a:t> </a:t>
+            </a:r>
+            <a:r>
+              <a:rPr dirty="0" err="1"/>
+              <a:t>el</a:t>
+            </a:r>
+            <a:r>
+              <a:rPr dirty="0"/>
+              <a:t> dataset </a:t>
+            </a:r>
+            <a:r>
+              <a:rPr dirty="0" err="1"/>
+              <a:t>completo</a:t>
+            </a:r>
+            <a:r>
+              <a:rPr dirty="0"/>
+              <a:t>.</a:t>
+            </a:r>
+          </a:p>
+          <a:p>
+            <a:endParaRPr dirty="0"/>
+          </a:p>
+          <a:p>
+            <a:r>
+              <a:rPr dirty="0"/>
+              <a:t>SI EL VIDEO VA CORTO, </a:t>
+            </a:r>
+            <a:r>
+              <a:rPr dirty="0" err="1"/>
+              <a:t>agregar</a:t>
+            </a:r>
+            <a:r>
+              <a:rPr dirty="0"/>
+              <a:t> </a:t>
+            </a:r>
+            <a:r>
+              <a:rPr dirty="0" err="1"/>
+              <a:t>aquí</a:t>
+            </a:r>
+            <a:r>
+              <a:rPr dirty="0"/>
+              <a:t>: </a:t>
+            </a:r>
+            <a:r>
+              <a:rPr dirty="0" err="1"/>
+              <a:t>el</a:t>
+            </a:r>
+            <a:r>
+              <a:rPr dirty="0"/>
+              <a:t> pipeline </a:t>
+            </a:r>
+            <a:r>
+              <a:rPr dirty="0" err="1"/>
+              <a:t>retiene</a:t>
+            </a:r>
+            <a:r>
+              <a:rPr dirty="0"/>
+              <a:t> </a:t>
+            </a:r>
+            <a:r>
+              <a:rPr dirty="0" err="1"/>
+              <a:t>el</a:t>
+            </a:r>
+            <a:r>
+              <a:rPr dirty="0"/>
+              <a:t> 72,9 </a:t>
+            </a:r>
+            <a:r>
+              <a:rPr dirty="0" err="1"/>
+              <a:t>por</a:t>
+            </a:r>
+            <a:r>
+              <a:rPr dirty="0"/>
+              <a:t> </a:t>
+            </a:r>
+            <a:r>
+              <a:rPr dirty="0" err="1"/>
+              <a:t>ciento</a:t>
+            </a:r>
+            <a:r>
+              <a:rPr dirty="0"/>
+              <a:t> de las </a:t>
+            </a:r>
+            <a:r>
+              <a:rPr dirty="0" err="1"/>
+              <a:t>filas</a:t>
+            </a:r>
+            <a:endParaRPr dirty="0"/>
+          </a:p>
+          <a:p>
+            <a:r>
+              <a:rPr dirty="0" err="1"/>
+              <a:t>originales</a:t>
+            </a:r>
+            <a:r>
+              <a:rPr dirty="0"/>
+              <a:t> y </a:t>
+            </a:r>
+            <a:r>
+              <a:rPr dirty="0" err="1"/>
+              <a:t>cada</a:t>
+            </a:r>
+            <a:r>
+              <a:rPr dirty="0"/>
+              <a:t> </a:t>
+            </a:r>
+            <a:r>
+              <a:rPr dirty="0" err="1"/>
+              <a:t>exclusión</a:t>
+            </a:r>
+            <a:r>
+              <a:rPr dirty="0"/>
+              <a:t> </a:t>
+            </a:r>
+            <a:r>
+              <a:rPr dirty="0" err="1"/>
+              <a:t>está</a:t>
+            </a:r>
+            <a:r>
+              <a:rPr dirty="0"/>
+              <a:t> </a:t>
+            </a:r>
+            <a:r>
+              <a:rPr dirty="0" err="1"/>
+              <a:t>cuantificada</a:t>
+            </a:r>
+            <a:r>
+              <a:rPr dirty="0"/>
+              <a:t> </a:t>
+            </a:r>
+            <a:r>
+              <a:rPr dirty="0" err="1"/>
+              <a:t>en</a:t>
+            </a:r>
+            <a:r>
+              <a:rPr dirty="0"/>
+              <a:t> </a:t>
+            </a:r>
+            <a:r>
+              <a:rPr dirty="0" err="1"/>
+              <a:t>una</a:t>
+            </a:r>
+            <a:r>
+              <a:rPr dirty="0"/>
+              <a:t> </a:t>
+            </a:r>
+            <a:r>
+              <a:rPr dirty="0" err="1"/>
+              <a:t>bitácora</a:t>
+            </a:r>
+            <a:r>
+              <a:rPr dirty="0"/>
+              <a:t> auditable.</a:t>
+            </a:r>
           </a:p>
         </p:txBody>
       </p:sp>
@@ -793,7 +1837,590 @@
           <a:bodyPr/>
           <a:lstStyle/>
           <a:p>
+            <a:r>
+              <a:rPr dirty="0"/>
+              <a:t>Este es </a:t>
+            </a:r>
+            <a:r>
+              <a:rPr dirty="0" err="1"/>
+              <a:t>el</a:t>
+            </a:r>
+            <a:r>
+              <a:rPr dirty="0"/>
+              <a:t> </a:t>
+            </a:r>
+            <a:r>
+              <a:rPr dirty="0" err="1"/>
+              <a:t>resultado</a:t>
+            </a:r>
+            <a:r>
+              <a:rPr dirty="0"/>
+              <a:t> central. Solo </a:t>
+            </a:r>
+            <a:r>
+              <a:rPr dirty="0" err="1"/>
+              <a:t>el</a:t>
+            </a:r>
+            <a:r>
+              <a:rPr dirty="0"/>
+              <a:t> 19 </a:t>
+            </a:r>
+            <a:r>
+              <a:rPr dirty="0" err="1"/>
+              <a:t>por</a:t>
+            </a:r>
+            <a:r>
+              <a:rPr dirty="0"/>
+              <a:t> </a:t>
+            </a:r>
+            <a:r>
+              <a:rPr dirty="0" err="1"/>
+              <a:t>ciento</a:t>
+            </a:r>
+            <a:r>
+              <a:rPr dirty="0"/>
+              <a:t> de </a:t>
+            </a:r>
+            <a:r>
+              <a:rPr dirty="0" err="1"/>
+              <a:t>los</a:t>
+            </a:r>
+            <a:r>
+              <a:rPr dirty="0"/>
+              <a:t> </a:t>
+            </a:r>
+            <a:r>
+              <a:rPr dirty="0" err="1"/>
+              <a:t>titulados</a:t>
+            </a:r>
+            <a:r>
+              <a:rPr dirty="0"/>
+              <a:t> </a:t>
+            </a:r>
+            <a:r>
+              <a:rPr dirty="0" err="1"/>
+              <a:t>egresa</a:t>
+            </a:r>
+            <a:r>
+              <a:rPr dirty="0"/>
+              <a:t> </a:t>
+            </a:r>
+            <a:r>
+              <a:rPr dirty="0" err="1"/>
+              <a:t>dentro</a:t>
+            </a:r>
+            <a:r>
+              <a:rPr dirty="0"/>
+              <a:t> del</a:t>
+            </a:r>
+          </a:p>
+          <a:p>
+            <a:r>
+              <a:rPr dirty="0" err="1"/>
+              <a:t>plazo</a:t>
+            </a:r>
+            <a:r>
+              <a:rPr dirty="0"/>
+              <a:t> que </a:t>
+            </a:r>
+            <a:r>
+              <a:rPr dirty="0" err="1"/>
+              <a:t>su</a:t>
+            </a:r>
+            <a:r>
+              <a:rPr dirty="0"/>
+              <a:t> </a:t>
+            </a:r>
+            <a:r>
+              <a:rPr dirty="0" err="1"/>
+              <a:t>propio</a:t>
+            </a:r>
+            <a:r>
+              <a:rPr dirty="0"/>
+              <a:t> plan </a:t>
+            </a:r>
+            <a:r>
+              <a:rPr dirty="0" err="1"/>
+              <a:t>declara</a:t>
+            </a:r>
+            <a:r>
+              <a:rPr dirty="0"/>
+              <a:t>. </a:t>
+            </a:r>
+            <a:r>
+              <a:rPr dirty="0" err="1"/>
+              <a:t>Dicho</a:t>
+            </a:r>
+            <a:r>
+              <a:rPr dirty="0"/>
+              <a:t> al </a:t>
+            </a:r>
+            <a:r>
+              <a:rPr dirty="0" err="1"/>
+              <a:t>revés</a:t>
+            </a:r>
+            <a:r>
+              <a:rPr dirty="0"/>
+              <a:t>: cuatro de </a:t>
+            </a:r>
+            <a:r>
+              <a:rPr dirty="0" err="1"/>
+              <a:t>cada</a:t>
+            </a:r>
+            <a:r>
+              <a:rPr dirty="0"/>
+              <a:t> </a:t>
+            </a:r>
+            <a:r>
+              <a:rPr dirty="0" err="1"/>
+              <a:t>cinco</a:t>
+            </a:r>
+            <a:r>
+              <a:rPr dirty="0"/>
+              <a:t> se </a:t>
+            </a:r>
+            <a:r>
+              <a:rPr dirty="0" err="1"/>
+              <a:t>titulan</a:t>
+            </a:r>
+            <a:r>
+              <a:rPr dirty="0"/>
+              <a:t> </a:t>
+            </a:r>
+            <a:r>
+              <a:rPr dirty="0" err="1"/>
+              <a:t>fuera</a:t>
+            </a:r>
             <a:endParaRPr dirty="0"/>
+          </a:p>
+          <a:p>
+            <a:r>
+              <a:rPr dirty="0"/>
+              <a:t>de </a:t>
+            </a:r>
+            <a:r>
+              <a:rPr dirty="0" err="1"/>
+              <a:t>plazo</a:t>
+            </a:r>
+            <a:r>
+              <a:rPr dirty="0"/>
+              <a:t>.</a:t>
+            </a:r>
+          </a:p>
+          <a:p>
+            <a:endParaRPr dirty="0"/>
+          </a:p>
+          <a:p>
+            <a:r>
+              <a:rPr dirty="0"/>
+              <a:t>El </a:t>
+            </a:r>
+            <a:r>
+              <a:rPr dirty="0" err="1"/>
+              <a:t>exceso</a:t>
+            </a:r>
+            <a:r>
+              <a:rPr dirty="0"/>
+              <a:t> </a:t>
+            </a:r>
+            <a:r>
+              <a:rPr dirty="0" err="1"/>
+              <a:t>promedio</a:t>
+            </a:r>
+            <a:r>
+              <a:rPr dirty="0"/>
+              <a:t> es de 2 coma 76 </a:t>
+            </a:r>
+            <a:r>
+              <a:rPr dirty="0" err="1"/>
+              <a:t>semestres</a:t>
+            </a:r>
+            <a:r>
+              <a:rPr dirty="0"/>
+              <a:t>, un 43 </a:t>
+            </a:r>
+            <a:r>
+              <a:rPr dirty="0" err="1"/>
+              <a:t>por</a:t>
+            </a:r>
+            <a:r>
+              <a:rPr dirty="0"/>
+              <a:t> </a:t>
+            </a:r>
+            <a:r>
+              <a:rPr dirty="0" err="1"/>
+              <a:t>ciento</a:t>
+            </a:r>
+            <a:r>
+              <a:rPr dirty="0"/>
+              <a:t> </a:t>
+            </a:r>
+            <a:r>
+              <a:rPr dirty="0" err="1"/>
+              <a:t>más</a:t>
+            </a:r>
+            <a:r>
+              <a:rPr dirty="0"/>
+              <a:t> de </a:t>
+            </a:r>
+            <a:r>
+              <a:rPr dirty="0" err="1"/>
+              <a:t>tiempo</a:t>
+            </a:r>
+            <a:r>
+              <a:rPr dirty="0"/>
+              <a:t> del</a:t>
+            </a:r>
+          </a:p>
+          <a:p>
+            <a:r>
+              <a:rPr dirty="0" err="1"/>
+              <a:t>previsto</a:t>
+            </a:r>
+            <a:r>
+              <a:rPr dirty="0"/>
+              <a:t>. Y </a:t>
+            </a:r>
+            <a:r>
+              <a:rPr dirty="0" err="1"/>
+              <a:t>el</a:t>
+            </a:r>
+            <a:r>
+              <a:rPr dirty="0"/>
+              <a:t> </a:t>
+            </a:r>
+            <a:r>
+              <a:rPr dirty="0" err="1"/>
+              <a:t>rezago</a:t>
+            </a:r>
+            <a:r>
+              <a:rPr dirty="0"/>
+              <a:t> </a:t>
+            </a:r>
+            <a:r>
+              <a:rPr dirty="0" err="1"/>
+              <a:t>severo</a:t>
+            </a:r>
+            <a:r>
+              <a:rPr dirty="0"/>
+              <a:t>, </a:t>
+            </a:r>
+            <a:r>
+              <a:rPr dirty="0" err="1"/>
+              <a:t>más</a:t>
+            </a:r>
+            <a:r>
+              <a:rPr dirty="0"/>
+              <a:t> de cuatro </a:t>
+            </a:r>
+            <a:r>
+              <a:rPr dirty="0" err="1"/>
+              <a:t>semestres</a:t>
+            </a:r>
+            <a:r>
+              <a:rPr dirty="0"/>
+              <a:t> de </a:t>
+            </a:r>
+            <a:r>
+              <a:rPr dirty="0" err="1"/>
+              <a:t>exceso</a:t>
+            </a:r>
+            <a:r>
+              <a:rPr dirty="0"/>
+              <a:t>, </a:t>
+            </a:r>
+            <a:r>
+              <a:rPr dirty="0" err="1"/>
+              <a:t>alcanza</a:t>
+            </a:r>
+            <a:r>
+              <a:rPr dirty="0"/>
+              <a:t> al 20 coma 4</a:t>
+            </a:r>
+          </a:p>
+          <a:p>
+            <a:r>
+              <a:rPr dirty="0" err="1"/>
+              <a:t>por</a:t>
+            </a:r>
+            <a:r>
+              <a:rPr dirty="0"/>
+              <a:t> </a:t>
+            </a:r>
+            <a:r>
+              <a:rPr dirty="0" err="1"/>
+              <a:t>ciento</a:t>
+            </a:r>
+            <a:r>
+              <a:rPr dirty="0"/>
+              <a:t>: </a:t>
+            </a:r>
+            <a:r>
+              <a:rPr dirty="0" err="1"/>
+              <a:t>prácticamente</a:t>
+            </a:r>
+            <a:r>
+              <a:rPr dirty="0"/>
+              <a:t> la </a:t>
+            </a:r>
+            <a:r>
+              <a:rPr dirty="0" err="1"/>
+              <a:t>misma</a:t>
+            </a:r>
+            <a:r>
+              <a:rPr dirty="0"/>
+              <a:t> </a:t>
+            </a:r>
+            <a:r>
+              <a:rPr dirty="0" err="1"/>
+              <a:t>proporción</a:t>
+            </a:r>
+            <a:r>
+              <a:rPr dirty="0"/>
+              <a:t> que </a:t>
+            </a:r>
+            <a:r>
+              <a:rPr dirty="0" err="1"/>
+              <a:t>logra</a:t>
+            </a:r>
+            <a:r>
+              <a:rPr dirty="0"/>
+              <a:t> </a:t>
+            </a:r>
+            <a:r>
+              <a:rPr dirty="0" err="1"/>
+              <a:t>titularse</a:t>
+            </a:r>
+            <a:r>
+              <a:rPr dirty="0"/>
+              <a:t> a </a:t>
+            </a:r>
+            <a:r>
+              <a:rPr dirty="0" err="1"/>
+              <a:t>tiempo</a:t>
+            </a:r>
+            <a:r>
+              <a:rPr dirty="0"/>
+              <a:t>.</a:t>
+            </a:r>
+          </a:p>
+          <a:p>
+            <a:endParaRPr dirty="0"/>
+          </a:p>
+          <a:p>
+            <a:r>
+              <a:rPr dirty="0" err="1"/>
+              <a:t>Agregado</a:t>
+            </a:r>
+            <a:r>
+              <a:rPr dirty="0"/>
+              <a:t>, </a:t>
+            </a:r>
+            <a:r>
+              <a:rPr dirty="0" err="1"/>
+              <a:t>el</a:t>
+            </a:r>
+            <a:r>
+              <a:rPr dirty="0"/>
+              <a:t> </a:t>
+            </a:r>
+            <a:r>
+              <a:rPr dirty="0" err="1"/>
+              <a:t>sistema</a:t>
+            </a:r>
+            <a:r>
+              <a:rPr dirty="0"/>
+              <a:t> </a:t>
+            </a:r>
+            <a:r>
+              <a:rPr dirty="0" err="1"/>
+              <a:t>acumula</a:t>
+            </a:r>
+            <a:r>
+              <a:rPr dirty="0"/>
+              <a:t> 3 coma 55 </a:t>
+            </a:r>
+            <a:r>
+              <a:rPr dirty="0" err="1"/>
+              <a:t>millones</a:t>
+            </a:r>
+            <a:r>
+              <a:rPr dirty="0"/>
+              <a:t> de </a:t>
+            </a:r>
+            <a:r>
+              <a:rPr dirty="0" err="1"/>
+              <a:t>semestres-estudiante</a:t>
+            </a:r>
+            <a:r>
+              <a:rPr dirty="0"/>
+              <a:t> </a:t>
+            </a:r>
+            <a:r>
+              <a:rPr dirty="0" err="1"/>
+              <a:t>por</a:t>
+            </a:r>
+            <a:r>
+              <a:rPr dirty="0"/>
+              <a:t> </a:t>
+            </a:r>
+            <a:r>
+              <a:rPr dirty="0" err="1"/>
+              <a:t>sobre</a:t>
+            </a:r>
+            <a:r>
+              <a:rPr dirty="0"/>
+              <a:t> lo</a:t>
+            </a:r>
+          </a:p>
+          <a:p>
+            <a:r>
+              <a:rPr dirty="0" err="1"/>
+              <a:t>planificado</a:t>
+            </a:r>
+            <a:r>
+              <a:rPr dirty="0"/>
+              <a:t> </a:t>
+            </a:r>
+            <a:r>
+              <a:rPr dirty="0" err="1"/>
+              <a:t>en</a:t>
+            </a:r>
+            <a:r>
+              <a:rPr dirty="0"/>
+              <a:t> </a:t>
+            </a:r>
+            <a:r>
+              <a:rPr dirty="0" err="1"/>
+              <a:t>el</a:t>
+            </a:r>
+            <a:r>
+              <a:rPr dirty="0"/>
+              <a:t> </a:t>
+            </a:r>
+            <a:r>
+              <a:rPr dirty="0" err="1"/>
+              <a:t>período</a:t>
+            </a:r>
+            <a:r>
+              <a:rPr dirty="0"/>
+              <a:t>.</a:t>
+            </a:r>
+          </a:p>
+          <a:p>
+            <a:endParaRPr dirty="0"/>
+          </a:p>
+          <a:p>
+            <a:r>
+              <a:rPr dirty="0"/>
+              <a:t>El </a:t>
+            </a:r>
+            <a:r>
+              <a:rPr dirty="0" err="1"/>
+              <a:t>gráfico</a:t>
+            </a:r>
+            <a:r>
+              <a:rPr dirty="0"/>
+              <a:t> de la </a:t>
+            </a:r>
+            <a:r>
+              <a:rPr dirty="0" err="1"/>
+              <a:t>izquierda</a:t>
+            </a:r>
+            <a:r>
+              <a:rPr dirty="0"/>
+              <a:t> </a:t>
+            </a:r>
+            <a:r>
+              <a:rPr dirty="0" err="1"/>
+              <a:t>muestra</a:t>
+            </a:r>
+            <a:r>
+              <a:rPr dirty="0"/>
+              <a:t> </a:t>
+            </a:r>
+            <a:r>
+              <a:rPr dirty="0" err="1"/>
+              <a:t>por</a:t>
+            </a:r>
+            <a:r>
+              <a:rPr dirty="0"/>
+              <a:t> </a:t>
+            </a:r>
+            <a:r>
+              <a:rPr dirty="0" err="1"/>
+              <a:t>qué</a:t>
+            </a:r>
+            <a:r>
+              <a:rPr dirty="0"/>
+              <a:t> </a:t>
+            </a:r>
+            <a:r>
+              <a:rPr dirty="0" err="1"/>
+              <a:t>reporto</a:t>
+            </a:r>
+            <a:r>
+              <a:rPr dirty="0"/>
+              <a:t> media y </a:t>
+            </a:r>
+            <a:r>
+              <a:rPr dirty="0" err="1"/>
+              <a:t>mediana</a:t>
+            </a:r>
+            <a:r>
+              <a:rPr dirty="0"/>
+              <a:t>: la </a:t>
+            </a:r>
+            <a:r>
+              <a:rPr dirty="0" err="1"/>
+              <a:t>distribución</a:t>
+            </a:r>
+            <a:r>
+              <a:rPr dirty="0"/>
+              <a:t> es</a:t>
+            </a:r>
+          </a:p>
+          <a:p>
+            <a:r>
+              <a:rPr dirty="0" err="1"/>
+              <a:t>asimétrica</a:t>
+            </a:r>
+            <a:r>
+              <a:rPr dirty="0"/>
+              <a:t>, con </a:t>
+            </a:r>
+            <a:r>
+              <a:rPr dirty="0" err="1"/>
+              <a:t>una</a:t>
+            </a:r>
+            <a:r>
+              <a:rPr dirty="0"/>
+              <a:t> cola </a:t>
+            </a:r>
+            <a:r>
+              <a:rPr dirty="0" err="1"/>
+              <a:t>larga</a:t>
+            </a:r>
+            <a:r>
+              <a:rPr dirty="0"/>
+              <a:t> que arrastra </a:t>
+            </a:r>
+            <a:r>
+              <a:rPr dirty="0" err="1"/>
+              <a:t>el</a:t>
+            </a:r>
+            <a:r>
+              <a:rPr dirty="0"/>
+              <a:t> </a:t>
+            </a:r>
+            <a:r>
+              <a:rPr dirty="0" err="1"/>
+              <a:t>promedio</a:t>
+            </a:r>
+            <a:r>
+              <a:rPr dirty="0"/>
+              <a:t>.</a:t>
+            </a:r>
           </a:p>
         </p:txBody>
       </p:sp>
@@ -861,7 +2488,549 @@
           <a:bodyPr/>
           <a:lstStyle/>
           <a:p>
+            <a:r>
+              <a:rPr dirty="0"/>
+              <a:t>El </a:t>
+            </a:r>
+            <a:r>
+              <a:rPr dirty="0" err="1"/>
+              <a:t>rezago</a:t>
+            </a:r>
+            <a:r>
+              <a:rPr dirty="0"/>
+              <a:t> </a:t>
+            </a:r>
+            <a:r>
+              <a:rPr dirty="0" err="1"/>
+              <a:t>tampoco</a:t>
+            </a:r>
+            <a:r>
+              <a:rPr dirty="0"/>
+              <a:t> se </a:t>
+            </a:r>
+            <a:r>
+              <a:rPr dirty="0" err="1"/>
+              <a:t>reparte</a:t>
+            </a:r>
+            <a:r>
+              <a:rPr dirty="0"/>
+              <a:t> de forma pareja.</a:t>
+            </a:r>
+          </a:p>
+          <a:p>
             <a:endParaRPr dirty="0"/>
+          </a:p>
+          <a:p>
+            <a:r>
+              <a:rPr dirty="0"/>
+              <a:t>Por </a:t>
+            </a:r>
+            <a:r>
+              <a:rPr dirty="0" err="1"/>
+              <a:t>área</a:t>
+            </a:r>
+            <a:r>
+              <a:rPr dirty="0"/>
+              <a:t> de </a:t>
+            </a:r>
+            <a:r>
+              <a:rPr dirty="0" err="1"/>
+              <a:t>conocimiento</a:t>
+            </a:r>
+            <a:r>
+              <a:rPr dirty="0"/>
+              <a:t>, Derecho </a:t>
+            </a:r>
+            <a:r>
+              <a:rPr dirty="0" err="1"/>
+              <a:t>triplica</a:t>
+            </a:r>
+            <a:r>
+              <a:rPr dirty="0"/>
+              <a:t> a </a:t>
+            </a:r>
+            <a:r>
+              <a:rPr dirty="0" err="1"/>
+              <a:t>Educación</a:t>
+            </a:r>
+            <a:r>
+              <a:rPr dirty="0"/>
+              <a:t>: 5,77 </a:t>
+            </a:r>
+            <a:r>
+              <a:rPr dirty="0" err="1"/>
+              <a:t>semestres</a:t>
+            </a:r>
+            <a:r>
+              <a:rPr dirty="0"/>
+              <a:t> </a:t>
+            </a:r>
+            <a:r>
+              <a:rPr dirty="0" err="1"/>
+              <a:t>frente</a:t>
+            </a:r>
+            <a:r>
+              <a:rPr dirty="0"/>
+              <a:t> a 1,93.</a:t>
+            </a:r>
+          </a:p>
+          <a:p>
+            <a:r>
+              <a:rPr dirty="0" err="1"/>
+              <a:t>Casi</a:t>
+            </a:r>
+            <a:r>
+              <a:rPr dirty="0"/>
+              <a:t> cuatro </a:t>
+            </a:r>
+            <a:r>
+              <a:rPr dirty="0" err="1"/>
+              <a:t>semestres</a:t>
+            </a:r>
+            <a:r>
+              <a:rPr dirty="0"/>
+              <a:t>, dos </a:t>
+            </a:r>
+            <a:r>
+              <a:rPr dirty="0" err="1"/>
+              <a:t>años</a:t>
+            </a:r>
+            <a:r>
+              <a:rPr dirty="0"/>
+              <a:t>, </a:t>
+            </a:r>
+            <a:r>
+              <a:rPr dirty="0" err="1"/>
+              <a:t>separan</a:t>
+            </a:r>
+            <a:r>
+              <a:rPr dirty="0"/>
+              <a:t> a la </a:t>
+            </a:r>
+            <a:r>
+              <a:rPr dirty="0" err="1"/>
+              <a:t>carrera</a:t>
+            </a:r>
+            <a:r>
+              <a:rPr dirty="0"/>
+              <a:t> </a:t>
+            </a:r>
+            <a:r>
+              <a:rPr dirty="0" err="1"/>
+              <a:t>más</a:t>
+            </a:r>
+            <a:r>
+              <a:rPr dirty="0"/>
+              <a:t> </a:t>
+            </a:r>
+            <a:r>
+              <a:rPr dirty="0" err="1"/>
+              <a:t>rezagada</a:t>
+            </a:r>
+            <a:r>
+              <a:rPr dirty="0"/>
+              <a:t> de la </a:t>
+            </a:r>
+            <a:r>
+              <a:rPr dirty="0" err="1"/>
+              <a:t>menos</a:t>
+            </a:r>
+            <a:r>
+              <a:rPr dirty="0"/>
+              <a:t> </a:t>
+            </a:r>
+            <a:r>
+              <a:rPr dirty="0" err="1"/>
+              <a:t>rezagada</a:t>
+            </a:r>
+            <a:r>
+              <a:rPr dirty="0"/>
+              <a:t>.</a:t>
+            </a:r>
+          </a:p>
+          <a:p>
+            <a:endParaRPr dirty="0"/>
+          </a:p>
+          <a:p>
+            <a:r>
+              <a:rPr dirty="0"/>
+              <a:t>Por </a:t>
+            </a:r>
+            <a:r>
+              <a:rPr dirty="0" err="1"/>
+              <a:t>tipo</a:t>
+            </a:r>
+            <a:r>
+              <a:rPr dirty="0"/>
+              <a:t> de </a:t>
+            </a:r>
+            <a:r>
+              <a:rPr dirty="0" err="1"/>
+              <a:t>institución</a:t>
+            </a:r>
+            <a:r>
+              <a:rPr dirty="0"/>
+              <a:t>, las </a:t>
+            </a:r>
+            <a:r>
+              <a:rPr dirty="0" err="1"/>
+              <a:t>universidades</a:t>
+            </a:r>
+            <a:r>
+              <a:rPr dirty="0"/>
+              <a:t> </a:t>
+            </a:r>
+            <a:r>
+              <a:rPr dirty="0" err="1"/>
+              <a:t>acumulan</a:t>
+            </a:r>
+            <a:r>
+              <a:rPr dirty="0"/>
+              <a:t> </a:t>
+            </a:r>
+            <a:r>
+              <a:rPr dirty="0" err="1"/>
+              <a:t>más</a:t>
+            </a:r>
+            <a:r>
+              <a:rPr dirty="0"/>
+              <a:t> </a:t>
+            </a:r>
+            <a:r>
+              <a:rPr dirty="0" err="1"/>
+              <a:t>rezago</a:t>
+            </a:r>
+            <a:r>
+              <a:rPr dirty="0"/>
+              <a:t> que </a:t>
+            </a:r>
+            <a:r>
+              <a:rPr dirty="0" err="1"/>
+              <a:t>los</a:t>
+            </a:r>
+            <a:r>
+              <a:rPr dirty="0"/>
+              <a:t> </a:t>
+            </a:r>
+            <a:r>
+              <a:rPr dirty="0" err="1"/>
+              <a:t>institutos</a:t>
+            </a:r>
+            <a:endParaRPr dirty="0"/>
+          </a:p>
+          <a:p>
+            <a:r>
+              <a:rPr dirty="0" err="1"/>
+              <a:t>profesionales</a:t>
+            </a:r>
+            <a:r>
+              <a:rPr dirty="0"/>
+              <a:t> y </a:t>
+            </a:r>
+            <a:r>
+              <a:rPr dirty="0" err="1"/>
+              <a:t>su</a:t>
+            </a:r>
+            <a:r>
+              <a:rPr dirty="0"/>
+              <a:t> </a:t>
+            </a:r>
+            <a:r>
+              <a:rPr dirty="0" err="1"/>
+              <a:t>tasa</a:t>
+            </a:r>
+            <a:r>
+              <a:rPr dirty="0"/>
+              <a:t> de </a:t>
+            </a:r>
+            <a:r>
+              <a:rPr dirty="0" err="1"/>
+              <a:t>titulación</a:t>
+            </a:r>
+            <a:r>
+              <a:rPr dirty="0"/>
+              <a:t> </a:t>
+            </a:r>
+            <a:r>
+              <a:rPr dirty="0" err="1"/>
+              <a:t>oportuna</a:t>
+            </a:r>
+            <a:r>
+              <a:rPr dirty="0"/>
+              <a:t> es </a:t>
+            </a:r>
+            <a:r>
+              <a:rPr dirty="0" err="1"/>
+              <a:t>menos</a:t>
+            </a:r>
+            <a:r>
+              <a:rPr dirty="0"/>
+              <a:t> de la </a:t>
+            </a:r>
+            <a:r>
+              <a:rPr dirty="0" err="1"/>
+              <a:t>mitad</a:t>
+            </a:r>
+            <a:r>
+              <a:rPr dirty="0"/>
+              <a:t>. </a:t>
+            </a:r>
+            <a:r>
+              <a:rPr dirty="0" err="1"/>
+              <a:t>Eso</a:t>
+            </a:r>
+            <a:r>
+              <a:rPr dirty="0"/>
+              <a:t> </a:t>
+            </a:r>
+            <a:r>
+              <a:rPr dirty="0" err="1"/>
+              <a:t>sugiere</a:t>
+            </a:r>
+            <a:r>
+              <a:rPr dirty="0"/>
+              <a:t> que la</a:t>
+            </a:r>
+          </a:p>
+          <a:p>
+            <a:r>
+              <a:rPr dirty="0" err="1"/>
+              <a:t>duración</a:t>
+            </a:r>
+            <a:r>
+              <a:rPr dirty="0"/>
+              <a:t> </a:t>
+            </a:r>
+            <a:r>
+              <a:rPr dirty="0" err="1"/>
+              <a:t>declarada</a:t>
+            </a:r>
+            <a:r>
+              <a:rPr dirty="0"/>
+              <a:t> es </a:t>
+            </a:r>
+            <a:r>
+              <a:rPr dirty="0" err="1"/>
+              <a:t>menos</a:t>
+            </a:r>
+            <a:r>
+              <a:rPr dirty="0"/>
+              <a:t> </a:t>
+            </a:r>
+            <a:r>
+              <a:rPr dirty="0" err="1"/>
+              <a:t>realista</a:t>
+            </a:r>
+            <a:r>
+              <a:rPr dirty="0"/>
+              <a:t> </a:t>
+            </a:r>
+            <a:r>
+              <a:rPr dirty="0" err="1"/>
+              <a:t>en</a:t>
+            </a:r>
+            <a:r>
+              <a:rPr dirty="0"/>
+              <a:t> </a:t>
+            </a:r>
+            <a:r>
+              <a:rPr dirty="0" err="1"/>
+              <a:t>carreras</a:t>
+            </a:r>
+            <a:r>
+              <a:rPr dirty="0"/>
+              <a:t> </a:t>
+            </a:r>
+            <a:r>
+              <a:rPr dirty="0" err="1"/>
+              <a:t>universitarias</a:t>
+            </a:r>
+            <a:r>
+              <a:rPr dirty="0"/>
+              <a:t> </a:t>
+            </a:r>
+            <a:r>
+              <a:rPr dirty="0" err="1"/>
+              <a:t>largas</a:t>
+            </a:r>
+            <a:r>
+              <a:rPr dirty="0"/>
+              <a:t>.</a:t>
+            </a:r>
+          </a:p>
+          <a:p>
+            <a:endParaRPr dirty="0"/>
+          </a:p>
+          <a:p>
+            <a:r>
+              <a:rPr dirty="0"/>
+              <a:t>Y </a:t>
+            </a:r>
+            <a:r>
+              <a:rPr dirty="0" err="1"/>
+              <a:t>por</a:t>
+            </a:r>
+            <a:r>
+              <a:rPr dirty="0"/>
+              <a:t> </a:t>
+            </a:r>
+            <a:r>
+              <a:rPr dirty="0" err="1"/>
+              <a:t>género</a:t>
+            </a:r>
+            <a:r>
+              <a:rPr dirty="0"/>
+              <a:t>, las </a:t>
+            </a:r>
+            <a:r>
+              <a:rPr dirty="0" err="1"/>
+              <a:t>mujeres</a:t>
+            </a:r>
+            <a:r>
+              <a:rPr dirty="0"/>
+              <a:t> se </a:t>
+            </a:r>
+            <a:r>
+              <a:rPr dirty="0" err="1"/>
+              <a:t>titulan</a:t>
+            </a:r>
+            <a:r>
+              <a:rPr dirty="0"/>
+              <a:t> 0 coma 93 </a:t>
+            </a:r>
+            <a:r>
+              <a:rPr dirty="0" err="1"/>
+              <a:t>semestres</a:t>
+            </a:r>
+            <a:r>
+              <a:rPr dirty="0"/>
+              <a:t> antes. Lo </a:t>
+            </a:r>
+            <a:r>
+              <a:rPr dirty="0" err="1"/>
+              <a:t>importante</a:t>
+            </a:r>
+            <a:r>
+              <a:rPr dirty="0"/>
+              <a:t> del panel</a:t>
+            </a:r>
+          </a:p>
+          <a:p>
+            <a:r>
+              <a:rPr dirty="0"/>
+              <a:t>derecho es que la </a:t>
+            </a:r>
+            <a:r>
+              <a:rPr dirty="0" err="1"/>
+              <a:t>brecha</a:t>
+            </a:r>
+            <a:r>
+              <a:rPr dirty="0"/>
+              <a:t> se </a:t>
+            </a:r>
+            <a:r>
+              <a:rPr dirty="0" err="1"/>
+              <a:t>sostiene</a:t>
+            </a:r>
+            <a:r>
+              <a:rPr dirty="0"/>
+              <a:t> </a:t>
+            </a:r>
+            <a:r>
+              <a:rPr dirty="0" err="1"/>
+              <a:t>en</a:t>
+            </a:r>
+            <a:r>
+              <a:rPr dirty="0"/>
+              <a:t> las </a:t>
+            </a:r>
+            <a:r>
+              <a:rPr dirty="0" err="1"/>
+              <a:t>diez</a:t>
+            </a:r>
+            <a:r>
+              <a:rPr dirty="0"/>
+              <a:t> </a:t>
+            </a:r>
+            <a:r>
+              <a:rPr dirty="0" err="1"/>
+              <a:t>áreas</a:t>
+            </a:r>
+            <a:r>
+              <a:rPr dirty="0"/>
+              <a:t> sin </a:t>
+            </a:r>
+            <a:r>
+              <a:rPr dirty="0" err="1"/>
+              <a:t>excepción</a:t>
+            </a:r>
+            <a:r>
+              <a:rPr dirty="0"/>
+              <a:t>: no es que </a:t>
+            </a:r>
+            <a:r>
+              <a:rPr dirty="0" err="1"/>
+              <a:t>estudien</a:t>
+            </a:r>
+            <a:endParaRPr dirty="0"/>
+          </a:p>
+          <a:p>
+            <a:r>
+              <a:rPr dirty="0" err="1"/>
+              <a:t>carreras</a:t>
+            </a:r>
+            <a:r>
+              <a:rPr dirty="0"/>
+              <a:t> </a:t>
+            </a:r>
+            <a:r>
+              <a:rPr dirty="0" err="1"/>
+              <a:t>más</a:t>
+            </a:r>
+            <a:r>
+              <a:rPr dirty="0"/>
+              <a:t> </a:t>
+            </a:r>
+            <a:r>
+              <a:rPr dirty="0" err="1"/>
+              <a:t>cortas</a:t>
+            </a:r>
+            <a:r>
+              <a:rPr dirty="0"/>
+              <a:t>, es que </a:t>
+            </a:r>
+            <a:r>
+              <a:rPr dirty="0" err="1"/>
+              <a:t>dentro</a:t>
+            </a:r>
+            <a:r>
+              <a:rPr dirty="0"/>
+              <a:t> de </a:t>
+            </a:r>
+            <a:r>
+              <a:rPr dirty="0" err="1"/>
+              <a:t>cada</a:t>
+            </a:r>
+            <a:r>
+              <a:rPr dirty="0"/>
+              <a:t> </a:t>
+            </a:r>
+            <a:r>
+              <a:rPr dirty="0" err="1"/>
+              <a:t>área</a:t>
+            </a:r>
+            <a:r>
+              <a:rPr dirty="0"/>
+              <a:t> se </a:t>
+            </a:r>
+            <a:r>
+              <a:rPr dirty="0" err="1"/>
+              <a:t>titulan</a:t>
+            </a:r>
+            <a:r>
+              <a:rPr dirty="0"/>
+              <a:t> antes.</a:t>
+            </a:r>
           </a:p>
         </p:txBody>
       </p:sp>
@@ -929,7 +3098,504 @@
           <a:bodyPr/>
           <a:lstStyle/>
           <a:p>
+            <a:r>
+              <a:rPr dirty="0"/>
+              <a:t>Este </a:t>
+            </a:r>
+            <a:r>
+              <a:rPr dirty="0" err="1"/>
+              <a:t>hallazgo</a:t>
+            </a:r>
+            <a:r>
+              <a:rPr dirty="0"/>
+              <a:t> no </a:t>
+            </a:r>
+            <a:r>
+              <a:rPr dirty="0" err="1"/>
+              <a:t>estaba</a:t>
+            </a:r>
+            <a:r>
+              <a:rPr dirty="0"/>
+              <a:t> </a:t>
+            </a:r>
+            <a:r>
+              <a:rPr dirty="0" err="1"/>
+              <a:t>en</a:t>
+            </a:r>
+            <a:r>
+              <a:rPr dirty="0"/>
+              <a:t> </a:t>
+            </a:r>
+            <a:r>
+              <a:rPr dirty="0" err="1"/>
+              <a:t>ninguna</a:t>
+            </a:r>
+            <a:r>
+              <a:rPr dirty="0"/>
+              <a:t> de las </a:t>
+            </a:r>
+            <a:r>
+              <a:rPr dirty="0" err="1"/>
+              <a:t>fases</a:t>
+            </a:r>
+            <a:r>
+              <a:rPr dirty="0"/>
+              <a:t> </a:t>
+            </a:r>
+            <a:r>
+              <a:rPr dirty="0" err="1"/>
+              <a:t>anteriores</a:t>
+            </a:r>
+            <a:r>
+              <a:rPr dirty="0"/>
+              <a:t>; </a:t>
+            </a:r>
+            <a:r>
+              <a:rPr dirty="0" err="1"/>
+              <a:t>apareció</a:t>
+            </a:r>
+            <a:r>
+              <a:rPr dirty="0"/>
+              <a:t> al </a:t>
+            </a:r>
+            <a:r>
+              <a:rPr dirty="0" err="1"/>
+              <a:t>mirar</a:t>
+            </a:r>
+            <a:r>
+              <a:rPr dirty="0"/>
+              <a:t> la </a:t>
+            </a:r>
+            <a:r>
+              <a:rPr dirty="0" err="1"/>
+              <a:t>serie</a:t>
+            </a:r>
             <a:endParaRPr dirty="0"/>
+          </a:p>
+          <a:p>
+            <a:r>
+              <a:rPr dirty="0"/>
+              <a:t>semestral </a:t>
+            </a:r>
+            <a:r>
+              <a:rPr dirty="0" err="1"/>
+              <a:t>en</a:t>
+            </a:r>
+            <a:r>
+              <a:rPr dirty="0"/>
+              <a:t> </a:t>
+            </a:r>
+            <a:r>
+              <a:rPr dirty="0" err="1"/>
+              <a:t>vez</a:t>
+            </a:r>
+            <a:r>
+              <a:rPr dirty="0"/>
+              <a:t> del </a:t>
+            </a:r>
+            <a:r>
+              <a:rPr dirty="0" err="1"/>
+              <a:t>promedio</a:t>
+            </a:r>
+            <a:r>
+              <a:rPr dirty="0"/>
+              <a:t> </a:t>
+            </a:r>
+            <a:r>
+              <a:rPr dirty="0" err="1"/>
+              <a:t>agregado</a:t>
+            </a:r>
+            <a:r>
+              <a:rPr dirty="0"/>
+              <a:t>.</a:t>
+            </a:r>
+          </a:p>
+          <a:p>
+            <a:endParaRPr dirty="0"/>
+          </a:p>
+          <a:p>
+            <a:r>
+              <a:rPr dirty="0"/>
+              <a:t>En 2020 se </a:t>
+            </a:r>
+            <a:r>
+              <a:rPr dirty="0" err="1"/>
+              <a:t>titularon</a:t>
+            </a:r>
+            <a:r>
+              <a:rPr dirty="0"/>
+              <a:t> </a:t>
+            </a:r>
+            <a:r>
+              <a:rPr dirty="0" err="1"/>
+              <a:t>unas</a:t>
+            </a:r>
+            <a:r>
+              <a:rPr dirty="0"/>
+              <a:t> 87 mil personas </a:t>
+            </a:r>
+            <a:r>
+              <a:rPr dirty="0" err="1"/>
+              <a:t>menos</a:t>
+            </a:r>
+            <a:r>
+              <a:rPr dirty="0"/>
+              <a:t> que </a:t>
+            </a:r>
+            <a:r>
+              <a:rPr dirty="0" err="1"/>
+              <a:t>en</a:t>
+            </a:r>
+            <a:r>
+              <a:rPr dirty="0"/>
+              <a:t> un </a:t>
+            </a:r>
+            <a:r>
+              <a:rPr dirty="0" err="1"/>
+              <a:t>año</a:t>
+            </a:r>
+            <a:r>
+              <a:rPr dirty="0"/>
+              <a:t> normal, y la </a:t>
+            </a:r>
+            <a:r>
+              <a:rPr dirty="0" err="1"/>
+              <a:t>sobreduración</a:t>
+            </a:r>
+            <a:endParaRPr dirty="0"/>
+          </a:p>
+          <a:p>
+            <a:r>
+              <a:rPr dirty="0"/>
+              <a:t>media </a:t>
+            </a:r>
+            <a:r>
+              <a:rPr dirty="0" err="1"/>
+              <a:t>tocó</a:t>
+            </a:r>
+            <a:r>
+              <a:rPr dirty="0"/>
+              <a:t> </a:t>
+            </a:r>
+            <a:r>
+              <a:rPr dirty="0" err="1"/>
+              <a:t>su</a:t>
+            </a:r>
+            <a:r>
+              <a:rPr dirty="0"/>
+              <a:t> </a:t>
+            </a:r>
+            <a:r>
+              <a:rPr dirty="0" err="1"/>
+              <a:t>mínimo</a:t>
+            </a:r>
+            <a:r>
+              <a:rPr dirty="0"/>
+              <a:t>. En 2021 </a:t>
+            </a:r>
+            <a:r>
+              <a:rPr dirty="0" err="1"/>
+              <a:t>el</a:t>
+            </a:r>
+            <a:r>
+              <a:rPr dirty="0"/>
+              <a:t> </a:t>
+            </a:r>
+            <a:r>
+              <a:rPr dirty="0" err="1"/>
+              <a:t>volumen</a:t>
+            </a:r>
+            <a:r>
+              <a:rPr dirty="0"/>
+              <a:t> se </a:t>
+            </a:r>
+            <a:r>
+              <a:rPr dirty="0" err="1"/>
+              <a:t>recuperó</a:t>
+            </a:r>
+            <a:r>
+              <a:rPr dirty="0"/>
+              <a:t> y la </a:t>
+            </a:r>
+            <a:r>
+              <a:rPr dirty="0" err="1"/>
+              <a:t>sobreduración</a:t>
+            </a:r>
+            <a:r>
+              <a:rPr dirty="0"/>
+              <a:t> </a:t>
+            </a:r>
+            <a:r>
+              <a:rPr dirty="0" err="1"/>
+              <a:t>alcanzó</a:t>
+            </a:r>
+            <a:r>
+              <a:rPr dirty="0"/>
+              <a:t> </a:t>
+            </a:r>
+            <a:r>
+              <a:rPr dirty="0" err="1"/>
+              <a:t>su</a:t>
+            </a:r>
+            <a:endParaRPr dirty="0"/>
+          </a:p>
+          <a:p>
+            <a:r>
+              <a:rPr dirty="0" err="1"/>
+              <a:t>máximo</a:t>
+            </a:r>
+            <a:r>
+              <a:rPr dirty="0"/>
+              <a:t>.</a:t>
+            </a:r>
+          </a:p>
+          <a:p>
+            <a:endParaRPr dirty="0"/>
+          </a:p>
+          <a:p>
+            <a:r>
+              <a:rPr dirty="0"/>
+              <a:t>La </a:t>
+            </a:r>
+            <a:r>
+              <a:rPr dirty="0" err="1"/>
+              <a:t>tentación</a:t>
+            </a:r>
+            <a:r>
+              <a:rPr dirty="0"/>
+              <a:t> es </a:t>
+            </a:r>
+            <a:r>
+              <a:rPr dirty="0" err="1"/>
+              <a:t>decir</a:t>
+            </a:r>
+            <a:r>
+              <a:rPr dirty="0"/>
+              <a:t> que 2020 </a:t>
+            </a:r>
+            <a:r>
+              <a:rPr dirty="0" err="1"/>
+              <a:t>fue</a:t>
+            </a:r>
+            <a:r>
+              <a:rPr dirty="0"/>
+              <a:t> un </a:t>
+            </a:r>
+            <a:r>
+              <a:rPr dirty="0" err="1"/>
+              <a:t>buen</a:t>
+            </a:r>
+            <a:r>
+              <a:rPr dirty="0"/>
+              <a:t> </a:t>
+            </a:r>
+            <a:r>
+              <a:rPr dirty="0" err="1"/>
+              <a:t>año</a:t>
+            </a:r>
+            <a:r>
+              <a:rPr dirty="0"/>
+              <a:t>. Pero no: las </a:t>
+            </a:r>
+            <a:r>
+              <a:rPr dirty="0" err="1"/>
+              <a:t>titulaciones</a:t>
+            </a:r>
+            <a:r>
+              <a:rPr dirty="0"/>
+              <a:t> se</a:t>
+            </a:r>
+          </a:p>
+          <a:p>
+            <a:r>
+              <a:rPr dirty="0"/>
+              <a:t>POSTERGARON. </a:t>
+            </a:r>
+            <a:r>
+              <a:rPr dirty="0" err="1"/>
+              <a:t>Quienes</a:t>
+            </a:r>
+            <a:r>
+              <a:rPr dirty="0"/>
+              <a:t> </a:t>
+            </a:r>
+            <a:r>
+              <a:rPr dirty="0" err="1"/>
+              <a:t>debían</a:t>
+            </a:r>
+            <a:r>
+              <a:rPr dirty="0"/>
+              <a:t> </a:t>
+            </a:r>
+            <a:r>
+              <a:rPr dirty="0" err="1"/>
+              <a:t>egresar</a:t>
+            </a:r>
+            <a:r>
+              <a:rPr dirty="0"/>
+              <a:t> </a:t>
+            </a:r>
+            <a:r>
+              <a:rPr dirty="0" err="1"/>
+              <a:t>en</a:t>
+            </a:r>
+            <a:r>
+              <a:rPr dirty="0"/>
+              <a:t> 2020 lo </a:t>
+            </a:r>
+            <a:r>
+              <a:rPr dirty="0" err="1"/>
+              <a:t>hicieron</a:t>
+            </a:r>
+            <a:r>
+              <a:rPr dirty="0"/>
+              <a:t> </a:t>
+            </a:r>
+            <a:r>
+              <a:rPr dirty="0" err="1"/>
+              <a:t>en</a:t>
+            </a:r>
+            <a:r>
+              <a:rPr dirty="0"/>
+              <a:t> 2021, con uno o dos </a:t>
+            </a:r>
+            <a:r>
+              <a:rPr dirty="0" err="1"/>
+              <a:t>semestres</a:t>
+            </a:r>
+            <a:endParaRPr dirty="0"/>
+          </a:p>
+          <a:p>
+            <a:r>
+              <a:rPr dirty="0" err="1"/>
+              <a:t>adicionales</a:t>
+            </a:r>
+            <a:r>
+              <a:rPr dirty="0"/>
+              <a:t> </a:t>
+            </a:r>
+            <a:r>
+              <a:rPr dirty="0" err="1"/>
+              <a:t>encima</a:t>
+            </a:r>
+            <a:r>
+              <a:rPr dirty="0"/>
+              <a:t>. El </a:t>
+            </a:r>
+            <a:r>
+              <a:rPr dirty="0" err="1"/>
+              <a:t>mínimo</a:t>
+            </a:r>
+            <a:r>
+              <a:rPr dirty="0"/>
+              <a:t> y </a:t>
+            </a:r>
+            <a:r>
+              <a:rPr dirty="0" err="1"/>
+              <a:t>el</a:t>
+            </a:r>
+            <a:r>
+              <a:rPr dirty="0"/>
+              <a:t> </a:t>
+            </a:r>
+            <a:r>
+              <a:rPr dirty="0" err="1"/>
+              <a:t>máximo</a:t>
+            </a:r>
+            <a:r>
+              <a:rPr dirty="0"/>
+              <a:t> son </a:t>
+            </a:r>
+            <a:r>
+              <a:rPr dirty="0" err="1"/>
+              <a:t>el</a:t>
+            </a:r>
+            <a:r>
+              <a:rPr dirty="0"/>
+              <a:t> </a:t>
+            </a:r>
+            <a:r>
+              <a:rPr dirty="0" err="1"/>
+              <a:t>mismo</a:t>
+            </a:r>
+            <a:r>
+              <a:rPr dirty="0"/>
+              <a:t> </a:t>
+            </a:r>
+            <a:r>
+              <a:rPr dirty="0" err="1"/>
+              <a:t>fenómeno</a:t>
+            </a:r>
+            <a:r>
+              <a:rPr dirty="0"/>
+              <a:t> visto </a:t>
+            </a:r>
+            <a:r>
+              <a:rPr dirty="0" err="1"/>
+              <a:t>en</a:t>
+            </a:r>
+            <a:r>
+              <a:rPr dirty="0"/>
+              <a:t> dos </a:t>
+            </a:r>
+            <a:r>
+              <a:rPr dirty="0" err="1"/>
+              <a:t>momentos</a:t>
+            </a:r>
+            <a:r>
+              <a:rPr dirty="0"/>
+              <a:t>, y</a:t>
+            </a:r>
+          </a:p>
+          <a:p>
+            <a:r>
+              <a:rPr dirty="0" err="1"/>
+              <a:t>el</a:t>
+            </a:r>
+            <a:r>
+              <a:rPr dirty="0"/>
+              <a:t> </a:t>
+            </a:r>
+            <a:r>
+              <a:rPr dirty="0" err="1"/>
+              <a:t>mecanismo</a:t>
+            </a:r>
+            <a:r>
+              <a:rPr dirty="0"/>
+              <a:t> es de </a:t>
+            </a:r>
+            <a:r>
+              <a:rPr dirty="0" err="1"/>
+              <a:t>desplazamiento</a:t>
+            </a:r>
+            <a:r>
+              <a:rPr dirty="0"/>
+              <a:t> </a:t>
+            </a:r>
+            <a:r>
+              <a:rPr dirty="0" err="1"/>
+              <a:t>administrativo</a:t>
+            </a:r>
+            <a:r>
+              <a:rPr dirty="0"/>
+              <a:t>, no de </a:t>
+            </a:r>
+            <a:r>
+              <a:rPr dirty="0" err="1"/>
+              <a:t>deterioro</a:t>
+            </a:r>
+            <a:r>
+              <a:rPr dirty="0"/>
+              <a:t> </a:t>
+            </a:r>
+            <a:r>
+              <a:rPr dirty="0" err="1"/>
+              <a:t>académico</a:t>
+            </a:r>
+            <a:r>
+              <a:rPr dirty="0"/>
+              <a:t>.</a:t>
+            </a:r>
           </a:p>
         </p:txBody>
       </p:sp>
@@ -997,7 +3663,531 @@
           <a:bodyPr/>
           <a:lstStyle/>
           <a:p>
+            <a:r>
+              <a:rPr dirty="0"/>
+              <a:t>Y </a:t>
+            </a:r>
+            <a:r>
+              <a:rPr dirty="0" err="1"/>
+              <a:t>aquí</a:t>
+            </a:r>
+            <a:r>
+              <a:rPr dirty="0"/>
+              <a:t> </a:t>
+            </a:r>
+            <a:r>
+              <a:rPr dirty="0" err="1"/>
+              <a:t>una</a:t>
+            </a:r>
+            <a:r>
+              <a:rPr dirty="0"/>
+              <a:t> </a:t>
+            </a:r>
+            <a:r>
+              <a:rPr dirty="0" err="1"/>
+              <a:t>limitación</a:t>
+            </a:r>
+            <a:r>
+              <a:rPr dirty="0"/>
+              <a:t> que </a:t>
+            </a:r>
+            <a:r>
+              <a:rPr dirty="0" err="1"/>
+              <a:t>condiciona</a:t>
+            </a:r>
+            <a:r>
+              <a:rPr dirty="0"/>
+              <a:t> </a:t>
+            </a:r>
+            <a:r>
+              <a:rPr dirty="0" err="1"/>
+              <a:t>todo</a:t>
+            </a:r>
+            <a:r>
+              <a:rPr dirty="0"/>
+              <a:t> lo anterior, y que </a:t>
+            </a:r>
+            <a:r>
+              <a:rPr dirty="0" err="1"/>
+              <a:t>creo</a:t>
+            </a:r>
+            <a:r>
+              <a:rPr dirty="0"/>
+              <a:t> que es uno de </a:t>
+            </a:r>
+            <a:r>
+              <a:rPr dirty="0" err="1"/>
+              <a:t>los</a:t>
+            </a:r>
             <a:endParaRPr dirty="0"/>
+          </a:p>
+          <a:p>
+            <a:r>
+              <a:rPr dirty="0" err="1"/>
+              <a:t>resultados</a:t>
+            </a:r>
+            <a:r>
+              <a:rPr dirty="0"/>
+              <a:t> </a:t>
+            </a:r>
+            <a:r>
+              <a:rPr dirty="0" err="1"/>
+              <a:t>más</a:t>
+            </a:r>
+            <a:r>
+              <a:rPr dirty="0"/>
+              <a:t> </a:t>
+            </a:r>
+            <a:r>
+              <a:rPr dirty="0" err="1"/>
+              <a:t>valiosos</a:t>
+            </a:r>
+            <a:r>
+              <a:rPr dirty="0"/>
+              <a:t> del </a:t>
+            </a:r>
+            <a:r>
+              <a:rPr dirty="0" err="1"/>
+              <a:t>proyecto</a:t>
+            </a:r>
+            <a:r>
+              <a:rPr dirty="0"/>
+              <a:t>.</a:t>
+            </a:r>
+          </a:p>
+          <a:p>
+            <a:endParaRPr dirty="0"/>
+          </a:p>
+          <a:p>
+            <a:r>
+              <a:rPr dirty="0"/>
+              <a:t>Una base de </a:t>
+            </a:r>
+            <a:r>
+              <a:rPr dirty="0" err="1"/>
+              <a:t>titulados</a:t>
+            </a:r>
+            <a:r>
+              <a:rPr dirty="0"/>
+              <a:t> solo </a:t>
+            </a:r>
+            <a:r>
+              <a:rPr dirty="0" err="1"/>
+              <a:t>contiene</a:t>
+            </a:r>
+            <a:r>
+              <a:rPr dirty="0"/>
+              <a:t> a </a:t>
+            </a:r>
+            <a:r>
+              <a:rPr dirty="0" err="1"/>
+              <a:t>quien</a:t>
+            </a:r>
+            <a:r>
+              <a:rPr dirty="0"/>
+              <a:t> </a:t>
+            </a:r>
+            <a:r>
+              <a:rPr dirty="0" err="1"/>
+              <a:t>terminó</a:t>
+            </a:r>
+            <a:r>
+              <a:rPr dirty="0"/>
+              <a:t>. De las </a:t>
+            </a:r>
+            <a:r>
+              <a:rPr dirty="0" err="1"/>
+              <a:t>cohortes</a:t>
+            </a:r>
+            <a:r>
+              <a:rPr dirty="0"/>
+              <a:t> </a:t>
+            </a:r>
+            <a:r>
+              <a:rPr dirty="0" err="1"/>
+              <a:t>recientes</a:t>
+            </a:r>
+            <a:r>
+              <a:rPr dirty="0"/>
+              <a:t> solo se</a:t>
+            </a:r>
+          </a:p>
+          <a:p>
+            <a:r>
+              <a:rPr dirty="0" err="1"/>
+              <a:t>han</a:t>
+            </a:r>
+            <a:r>
+              <a:rPr dirty="0"/>
+              <a:t> </a:t>
+            </a:r>
+            <a:r>
+              <a:rPr dirty="0" err="1"/>
+              <a:t>titulado</a:t>
+            </a:r>
+            <a:r>
+              <a:rPr dirty="0"/>
+              <a:t> </a:t>
+            </a:r>
+            <a:r>
+              <a:rPr dirty="0" err="1"/>
+              <a:t>los</a:t>
+            </a:r>
+            <a:r>
+              <a:rPr dirty="0"/>
+              <a:t> </a:t>
+            </a:r>
+            <a:r>
+              <a:rPr dirty="0" err="1"/>
+              <a:t>excepcionalmente</a:t>
+            </a:r>
+            <a:r>
+              <a:rPr dirty="0"/>
+              <a:t> </a:t>
+            </a:r>
+            <a:r>
+              <a:rPr dirty="0" err="1"/>
+              <a:t>rápidos</a:t>
+            </a:r>
+            <a:r>
+              <a:rPr dirty="0"/>
+              <a:t>, </a:t>
+            </a:r>
+            <a:r>
+              <a:rPr dirty="0" err="1"/>
+              <a:t>porque</a:t>
+            </a:r>
+            <a:r>
+              <a:rPr dirty="0"/>
+              <a:t> son </a:t>
+            </a:r>
+            <a:r>
+              <a:rPr dirty="0" err="1"/>
+              <a:t>los</a:t>
+            </a:r>
+            <a:r>
+              <a:rPr dirty="0"/>
+              <a:t> </a:t>
+            </a:r>
+            <a:r>
+              <a:rPr dirty="0" err="1"/>
+              <a:t>únicos</a:t>
+            </a:r>
+            <a:r>
+              <a:rPr dirty="0"/>
+              <a:t> que </a:t>
+            </a:r>
+            <a:r>
+              <a:rPr dirty="0" err="1"/>
+              <a:t>alcanzaron</a:t>
+            </a:r>
+            <a:r>
+              <a:rPr dirty="0"/>
+              <a:t> a</a:t>
+            </a:r>
+          </a:p>
+          <a:p>
+            <a:r>
+              <a:rPr dirty="0" err="1"/>
+              <a:t>hacerlo</a:t>
+            </a:r>
+            <a:r>
+              <a:rPr dirty="0"/>
+              <a:t>. De las </a:t>
+            </a:r>
+            <a:r>
+              <a:rPr dirty="0" err="1"/>
+              <a:t>cohortes</a:t>
+            </a:r>
+            <a:r>
+              <a:rPr dirty="0"/>
+              <a:t> </a:t>
+            </a:r>
+            <a:r>
+              <a:rPr dirty="0" err="1"/>
+              <a:t>antiguas</a:t>
+            </a:r>
+            <a:r>
+              <a:rPr dirty="0"/>
+              <a:t>, </a:t>
+            </a:r>
+            <a:r>
+              <a:rPr dirty="0" err="1"/>
+              <a:t>en</a:t>
+            </a:r>
+            <a:r>
+              <a:rPr dirty="0"/>
+              <a:t> </a:t>
+            </a:r>
+            <a:r>
+              <a:rPr dirty="0" err="1"/>
+              <a:t>cambio</a:t>
+            </a:r>
+            <a:r>
+              <a:rPr dirty="0"/>
+              <a:t>, </a:t>
+            </a:r>
+            <a:r>
+              <a:rPr dirty="0" err="1"/>
+              <a:t>los</a:t>
+            </a:r>
+            <a:r>
+              <a:rPr dirty="0"/>
+              <a:t> que </a:t>
+            </a:r>
+            <a:r>
+              <a:rPr dirty="0" err="1"/>
+              <a:t>aparecen</a:t>
+            </a:r>
+            <a:r>
+              <a:rPr dirty="0"/>
+              <a:t> son </a:t>
+            </a:r>
+            <a:r>
+              <a:rPr dirty="0" err="1"/>
+              <a:t>los</a:t>
+            </a:r>
+            <a:r>
+              <a:rPr dirty="0"/>
+              <a:t> </a:t>
+            </a:r>
+            <a:r>
+              <a:rPr dirty="0" err="1"/>
+              <a:t>extremadamente</a:t>
+            </a:r>
+            <a:endParaRPr dirty="0"/>
+          </a:p>
+          <a:p>
+            <a:r>
+              <a:rPr dirty="0" err="1"/>
+              <a:t>rezagados</a:t>
+            </a:r>
+            <a:r>
+              <a:rPr dirty="0"/>
+              <a:t>.</a:t>
+            </a:r>
+          </a:p>
+          <a:p>
+            <a:endParaRPr dirty="0"/>
+          </a:p>
+          <a:p>
+            <a:r>
+              <a:rPr dirty="0" err="1"/>
+              <a:t>Ninguna</a:t>
+            </a:r>
+            <a:r>
+              <a:rPr dirty="0"/>
+              <a:t> </a:t>
+            </a:r>
+            <a:r>
+              <a:rPr dirty="0" err="1"/>
+              <a:t>cohorte</a:t>
+            </a:r>
+            <a:r>
+              <a:rPr dirty="0"/>
+              <a:t> </a:t>
+            </a:r>
+            <a:r>
+              <a:rPr dirty="0" err="1"/>
+              <a:t>está</a:t>
+            </a:r>
+            <a:r>
+              <a:rPr dirty="0"/>
+              <a:t> </a:t>
+            </a:r>
+            <a:r>
+              <a:rPr dirty="0" err="1"/>
+              <a:t>completa</a:t>
+            </a:r>
+            <a:r>
+              <a:rPr dirty="0"/>
+              <a:t>, y lo </a:t>
+            </a:r>
+            <a:r>
+              <a:rPr dirty="0" err="1"/>
+              <a:t>están</a:t>
+            </a:r>
+            <a:r>
+              <a:rPr dirty="0"/>
+              <a:t> </a:t>
+            </a:r>
+            <a:r>
+              <a:rPr dirty="0" err="1"/>
+              <a:t>en</a:t>
+            </a:r>
+            <a:r>
+              <a:rPr dirty="0"/>
+              <a:t> </a:t>
+            </a:r>
+            <a:r>
+              <a:rPr dirty="0" err="1"/>
+              <a:t>direcciones</a:t>
+            </a:r>
+            <a:r>
+              <a:rPr dirty="0"/>
+              <a:t> </a:t>
+            </a:r>
+            <a:r>
+              <a:rPr dirty="0" err="1"/>
+              <a:t>opuestas</a:t>
+            </a:r>
+            <a:r>
+              <a:rPr dirty="0"/>
+              <a:t>. Por </a:t>
+            </a:r>
+            <a:r>
+              <a:rPr dirty="0" err="1"/>
+              <a:t>eso</a:t>
+            </a:r>
+            <a:r>
+              <a:rPr dirty="0"/>
+              <a:t> </a:t>
+            </a:r>
+            <a:r>
+              <a:rPr dirty="0" err="1"/>
+              <a:t>el</a:t>
+            </a:r>
+            <a:r>
+              <a:rPr dirty="0"/>
+              <a:t> </a:t>
+            </a:r>
+            <a:r>
+              <a:rPr dirty="0" err="1"/>
+              <a:t>descenso</a:t>
+            </a:r>
+            <a:endParaRPr dirty="0"/>
+          </a:p>
+          <a:p>
+            <a:r>
+              <a:rPr dirty="0"/>
+              <a:t>de la </a:t>
+            </a:r>
+            <a:r>
+              <a:rPr dirty="0" err="1"/>
+              <a:t>serie</a:t>
+            </a:r>
+            <a:r>
+              <a:rPr dirty="0"/>
+              <a:t> </a:t>
+            </a:r>
+            <a:r>
+              <a:rPr dirty="0" err="1"/>
+              <a:t>desde</a:t>
+            </a:r>
+            <a:r>
+              <a:rPr dirty="0"/>
+              <a:t> 2024 no </a:t>
+            </a:r>
+            <a:r>
+              <a:rPr dirty="0" err="1"/>
+              <a:t>puede</a:t>
+            </a:r>
+            <a:r>
+              <a:rPr dirty="0"/>
+              <a:t> </a:t>
+            </a:r>
+            <a:r>
+              <a:rPr dirty="0" err="1"/>
+              <a:t>leerse</a:t>
+            </a:r>
+            <a:r>
+              <a:rPr dirty="0"/>
+              <a:t> </a:t>
+            </a:r>
+            <a:r>
+              <a:rPr dirty="0" err="1"/>
+              <a:t>como</a:t>
+            </a:r>
+            <a:r>
+              <a:rPr dirty="0"/>
+              <a:t> </a:t>
+            </a:r>
+            <a:r>
+              <a:rPr dirty="0" err="1"/>
+              <a:t>una</a:t>
+            </a:r>
+            <a:r>
+              <a:rPr dirty="0"/>
+              <a:t> </a:t>
+            </a:r>
+            <a:r>
+              <a:rPr dirty="0" err="1"/>
+              <a:t>mejora</a:t>
+            </a:r>
+            <a:r>
+              <a:rPr dirty="0"/>
+              <a:t> del </a:t>
+            </a:r>
+            <a:r>
+              <a:rPr dirty="0" err="1"/>
+              <a:t>sistema</a:t>
+            </a:r>
+            <a:r>
+              <a:rPr dirty="0"/>
+              <a:t>. Es </a:t>
+            </a:r>
+            <a:r>
+              <a:rPr dirty="0" err="1"/>
+              <a:t>una</a:t>
+            </a:r>
+            <a:r>
+              <a:rPr dirty="0"/>
+              <a:t> </a:t>
+            </a:r>
+            <a:r>
+              <a:rPr dirty="0" err="1"/>
+              <a:t>limitación</a:t>
+            </a:r>
+            <a:r>
+              <a:rPr dirty="0"/>
+              <a:t> de</a:t>
+            </a:r>
+          </a:p>
+          <a:p>
+            <a:r>
+              <a:rPr dirty="0"/>
+              <a:t>la </a:t>
+            </a:r>
+            <a:r>
+              <a:rPr dirty="0" err="1"/>
+              <a:t>fuente</a:t>
+            </a:r>
+            <a:r>
+              <a:rPr dirty="0"/>
+              <a:t>, no del </a:t>
+            </a:r>
+            <a:r>
+              <a:rPr dirty="0" err="1"/>
+              <a:t>procesamiento</a:t>
+            </a:r>
+            <a:r>
+              <a:rPr dirty="0"/>
+              <a:t>, y </a:t>
+            </a:r>
+            <a:r>
+              <a:rPr dirty="0" err="1"/>
+              <a:t>declararla</a:t>
+            </a:r>
+            <a:r>
+              <a:rPr dirty="0"/>
+              <a:t> es </a:t>
+            </a:r>
+            <a:r>
+              <a:rPr dirty="0" err="1"/>
+              <a:t>parte</a:t>
+            </a:r>
+            <a:r>
+              <a:rPr dirty="0"/>
+              <a:t> del </a:t>
+            </a:r>
+            <a:r>
+              <a:rPr dirty="0" err="1"/>
+              <a:t>resultado</a:t>
+            </a:r>
+            <a:r>
+              <a:rPr dirty="0"/>
+              <a:t>.</a:t>
+            </a:r>
           </a:p>
         </p:txBody>
       </p:sp>
@@ -1065,7 +4255,655 @@
           <a:bodyPr/>
           <a:lstStyle/>
           <a:p>
+            <a:r>
+              <a:rPr dirty="0" err="1"/>
+              <a:t>Sobre</a:t>
+            </a:r>
+            <a:r>
+              <a:rPr dirty="0"/>
+              <a:t> </a:t>
+            </a:r>
+            <a:r>
+              <a:rPr dirty="0" err="1"/>
+              <a:t>el</a:t>
+            </a:r>
+            <a:r>
+              <a:rPr dirty="0"/>
+              <a:t> </a:t>
+            </a:r>
+            <a:r>
+              <a:rPr dirty="0" err="1"/>
+              <a:t>trabajo</a:t>
+            </a:r>
+            <a:r>
+              <a:rPr dirty="0"/>
+              <a:t> </a:t>
+            </a:r>
+            <a:r>
+              <a:rPr dirty="0" err="1"/>
+              <a:t>técnico</a:t>
+            </a:r>
+            <a:r>
+              <a:rPr dirty="0"/>
+              <a:t>: </a:t>
+            </a:r>
+            <a:r>
+              <a:rPr dirty="0" err="1"/>
+              <a:t>el</a:t>
+            </a:r>
+            <a:r>
+              <a:rPr dirty="0"/>
+              <a:t> </a:t>
+            </a:r>
+            <a:r>
+              <a:rPr dirty="0" err="1"/>
+              <a:t>proyecto</a:t>
+            </a:r>
+            <a:r>
+              <a:rPr dirty="0"/>
+              <a:t> </a:t>
+            </a:r>
+            <a:r>
+              <a:rPr dirty="0" err="1"/>
+              <a:t>tiene</a:t>
+            </a:r>
+            <a:r>
+              <a:rPr dirty="0"/>
+              <a:t> 73 </a:t>
+            </a:r>
+            <a:r>
+              <a:rPr dirty="0" err="1"/>
+              <a:t>pruebas</a:t>
+            </a:r>
+            <a:r>
+              <a:rPr dirty="0"/>
+              <a:t> </a:t>
+            </a:r>
+            <a:r>
+              <a:rPr dirty="0" err="1"/>
+              <a:t>automatizadas</a:t>
+            </a:r>
+            <a:r>
+              <a:rPr dirty="0"/>
+              <a:t> que </a:t>
+            </a:r>
+            <a:r>
+              <a:rPr dirty="0" err="1"/>
+              <a:t>cubren</a:t>
+            </a:r>
+            <a:r>
+              <a:rPr dirty="0"/>
+              <a:t> </a:t>
+            </a:r>
+            <a:r>
+              <a:rPr dirty="0" err="1"/>
+              <a:t>casos</a:t>
+            </a:r>
             <a:endParaRPr dirty="0"/>
+          </a:p>
+          <a:p>
+            <a:r>
+              <a:rPr dirty="0" err="1"/>
+              <a:t>normales</a:t>
+            </a:r>
+            <a:r>
+              <a:rPr dirty="0"/>
+              <a:t>, </a:t>
+            </a:r>
+            <a:r>
+              <a:rPr dirty="0" err="1"/>
+              <a:t>límite</a:t>
+            </a:r>
+            <a:r>
+              <a:rPr dirty="0"/>
+              <a:t> y </a:t>
+            </a:r>
+            <a:r>
+              <a:rPr dirty="0" err="1"/>
+              <a:t>excepciones</a:t>
+            </a:r>
+            <a:r>
+              <a:rPr dirty="0"/>
+              <a:t>, y 9 </a:t>
+            </a:r>
+            <a:r>
+              <a:rPr dirty="0" err="1"/>
+              <a:t>reglas</a:t>
+            </a:r>
+            <a:r>
+              <a:rPr dirty="0"/>
+              <a:t> de </a:t>
+            </a:r>
+            <a:r>
+              <a:rPr dirty="0" err="1"/>
+              <a:t>coherencia</a:t>
+            </a:r>
+            <a:r>
+              <a:rPr dirty="0"/>
+              <a:t> del </a:t>
+            </a:r>
+            <a:r>
+              <a:rPr dirty="0" err="1"/>
+              <a:t>dominio</a:t>
+            </a:r>
+            <a:r>
+              <a:rPr dirty="0"/>
+              <a:t>, </a:t>
+            </a:r>
+            <a:r>
+              <a:rPr dirty="0" err="1"/>
+              <a:t>todas</a:t>
+            </a:r>
+            <a:r>
+              <a:rPr dirty="0"/>
+              <a:t> </a:t>
+            </a:r>
+            <a:r>
+              <a:rPr dirty="0" err="1"/>
+              <a:t>aprobadas</a:t>
+            </a:r>
+            <a:r>
+              <a:rPr dirty="0"/>
+              <a:t>.</a:t>
+            </a:r>
+          </a:p>
+          <a:p>
+            <a:endParaRPr dirty="0"/>
+          </a:p>
+          <a:p>
+            <a:r>
+              <a:rPr dirty="0"/>
+              <a:t>Los </a:t>
+            </a:r>
+            <a:r>
+              <a:rPr dirty="0" err="1"/>
+              <a:t>algoritmos</a:t>
+            </a:r>
+            <a:r>
+              <a:rPr dirty="0"/>
+              <a:t> se </a:t>
+            </a:r>
+            <a:r>
+              <a:rPr dirty="0" err="1"/>
+              <a:t>implementaron</a:t>
+            </a:r>
+            <a:r>
+              <a:rPr dirty="0"/>
+              <a:t> </a:t>
+            </a:r>
+            <a:r>
+              <a:rPr dirty="0" err="1"/>
+              <a:t>desde</a:t>
+            </a:r>
+            <a:r>
+              <a:rPr dirty="0"/>
+              <a:t> cero y se </a:t>
+            </a:r>
+            <a:r>
+              <a:rPr dirty="0" err="1"/>
+              <a:t>verificaron</a:t>
+            </a:r>
+            <a:r>
+              <a:rPr dirty="0"/>
+              <a:t> contra pandas, sorted y</a:t>
+            </a:r>
+          </a:p>
+          <a:p>
+            <a:r>
+              <a:rPr dirty="0"/>
+              <a:t>NumPy ANTES de </a:t>
+            </a:r>
+            <a:r>
+              <a:rPr dirty="0" err="1"/>
+              <a:t>medir</a:t>
+            </a:r>
+            <a:r>
+              <a:rPr dirty="0"/>
+              <a:t> </a:t>
+            </a:r>
+            <a:r>
+              <a:rPr dirty="0" err="1"/>
+              <a:t>su</a:t>
+            </a:r>
+            <a:r>
+              <a:rPr dirty="0"/>
+              <a:t> </a:t>
+            </a:r>
+            <a:r>
+              <a:rPr dirty="0" err="1"/>
+              <a:t>tiempo</a:t>
+            </a:r>
+            <a:r>
+              <a:rPr dirty="0"/>
+              <a:t>: </a:t>
+            </a:r>
+            <a:r>
+              <a:rPr dirty="0" err="1"/>
+              <a:t>medir</a:t>
+            </a:r>
+            <a:r>
+              <a:rPr dirty="0"/>
+              <a:t> un </a:t>
+            </a:r>
+            <a:r>
+              <a:rPr dirty="0" err="1"/>
+              <a:t>algoritmo</a:t>
+            </a:r>
+            <a:r>
+              <a:rPr dirty="0"/>
+              <a:t> </a:t>
+            </a:r>
+            <a:r>
+              <a:rPr dirty="0" err="1"/>
+              <a:t>incorrecto</a:t>
+            </a:r>
+            <a:r>
+              <a:rPr dirty="0"/>
+              <a:t> no </a:t>
+            </a:r>
+            <a:r>
+              <a:rPr dirty="0" err="1"/>
+              <a:t>tiene</a:t>
+            </a:r>
+            <a:r>
+              <a:rPr dirty="0"/>
+              <a:t> </a:t>
+            </a:r>
+            <a:r>
+              <a:rPr dirty="0" err="1"/>
+              <a:t>sentido</a:t>
+            </a:r>
+            <a:r>
+              <a:rPr dirty="0"/>
+              <a:t>.</a:t>
+            </a:r>
+          </a:p>
+          <a:p>
+            <a:endParaRPr dirty="0"/>
+          </a:p>
+          <a:p>
+            <a:r>
+              <a:rPr dirty="0"/>
+              <a:t>Las curvas log-log </a:t>
+            </a:r>
+            <a:r>
+              <a:rPr dirty="0" err="1"/>
+              <a:t>confirmaron</a:t>
+            </a:r>
+            <a:r>
+              <a:rPr dirty="0"/>
+              <a:t> las </a:t>
+            </a:r>
+            <a:r>
+              <a:rPr dirty="0" err="1"/>
+              <a:t>cotas</a:t>
+            </a:r>
+            <a:r>
+              <a:rPr dirty="0"/>
+              <a:t> </a:t>
+            </a:r>
+            <a:r>
+              <a:rPr dirty="0" err="1"/>
+              <a:t>teóricas</a:t>
+            </a:r>
+            <a:r>
+              <a:rPr dirty="0"/>
+              <a:t>, </a:t>
+            </a:r>
+            <a:r>
+              <a:rPr dirty="0" err="1"/>
+              <a:t>pero</a:t>
+            </a:r>
+            <a:r>
+              <a:rPr dirty="0"/>
+              <a:t> </a:t>
+            </a:r>
+            <a:r>
+              <a:rPr dirty="0" err="1"/>
+              <a:t>también</a:t>
+            </a:r>
+            <a:r>
+              <a:rPr dirty="0"/>
+              <a:t> </a:t>
+            </a:r>
+            <a:r>
+              <a:rPr dirty="0" err="1"/>
+              <a:t>mostraron</a:t>
+            </a:r>
+            <a:r>
+              <a:rPr dirty="0"/>
+              <a:t> </a:t>
+            </a:r>
+            <a:r>
+              <a:rPr dirty="0" err="1"/>
+              <a:t>dónde</a:t>
+            </a:r>
+            <a:r>
+              <a:rPr dirty="0"/>
+              <a:t> la</a:t>
+            </a:r>
+          </a:p>
+          <a:p>
+            <a:r>
+              <a:rPr dirty="0" err="1"/>
+              <a:t>teoría</a:t>
+            </a:r>
+            <a:r>
+              <a:rPr dirty="0"/>
+              <a:t> no basta: </a:t>
+            </a:r>
+            <a:r>
+              <a:rPr dirty="0" err="1"/>
+              <a:t>quickselect</a:t>
+            </a:r>
+            <a:r>
+              <a:rPr dirty="0"/>
+              <a:t> es </a:t>
+            </a:r>
+            <a:r>
+              <a:rPr dirty="0" err="1"/>
+              <a:t>orden</a:t>
+            </a:r>
+            <a:r>
+              <a:rPr dirty="0"/>
+              <a:t> n </a:t>
+            </a:r>
+            <a:r>
+              <a:rPr dirty="0" err="1"/>
+              <a:t>en</a:t>
+            </a:r>
+            <a:r>
+              <a:rPr dirty="0"/>
+              <a:t> </a:t>
+            </a:r>
+            <a:r>
+              <a:rPr dirty="0" err="1"/>
+              <a:t>comparaciones</a:t>
+            </a:r>
+            <a:r>
+              <a:rPr dirty="0"/>
+              <a:t> y sin embargo </a:t>
+            </a:r>
+            <a:r>
+              <a:rPr dirty="0" err="1"/>
+              <a:t>escala</a:t>
+            </a:r>
+            <a:r>
+              <a:rPr dirty="0"/>
+              <a:t> </a:t>
+            </a:r>
+            <a:r>
+              <a:rPr dirty="0" err="1"/>
+              <a:t>como</a:t>
+            </a:r>
+            <a:r>
+              <a:rPr dirty="0"/>
+              <a:t> n</a:t>
+            </a:r>
+          </a:p>
+          <a:p>
+            <a:r>
+              <a:rPr dirty="0" err="1"/>
+              <a:t>elevado</a:t>
+            </a:r>
+            <a:r>
+              <a:rPr dirty="0"/>
+              <a:t> a 1,22, </a:t>
+            </a:r>
+            <a:r>
+              <a:rPr dirty="0" err="1"/>
+              <a:t>porque</a:t>
+            </a:r>
+            <a:r>
+              <a:rPr dirty="0"/>
+              <a:t> </a:t>
+            </a:r>
+            <a:r>
+              <a:rPr dirty="0" err="1"/>
+              <a:t>cada</a:t>
+            </a:r>
+            <a:r>
+              <a:rPr dirty="0"/>
+              <a:t> </a:t>
+            </a:r>
+            <a:r>
+              <a:rPr dirty="0" err="1"/>
+              <a:t>nivel</a:t>
+            </a:r>
+            <a:r>
+              <a:rPr dirty="0"/>
+              <a:t> de </a:t>
+            </a:r>
+            <a:r>
+              <a:rPr dirty="0" err="1"/>
+              <a:t>recursión</a:t>
+            </a:r>
+            <a:r>
+              <a:rPr dirty="0"/>
+              <a:t> </a:t>
+            </a:r>
+            <a:r>
+              <a:rPr dirty="0" err="1"/>
+              <a:t>asigna</a:t>
+            </a:r>
+            <a:r>
+              <a:rPr dirty="0"/>
+              <a:t> </a:t>
+            </a:r>
+            <a:r>
+              <a:rPr dirty="0" err="1"/>
+              <a:t>tres</a:t>
+            </a:r>
+            <a:r>
+              <a:rPr dirty="0"/>
+              <a:t> </a:t>
+            </a:r>
+            <a:r>
+              <a:rPr dirty="0" err="1"/>
+              <a:t>listas</a:t>
+            </a:r>
+            <a:r>
+              <a:rPr dirty="0"/>
+              <a:t> </a:t>
+            </a:r>
+            <a:r>
+              <a:rPr dirty="0" err="1"/>
+              <a:t>nuevas</a:t>
+            </a:r>
+            <a:r>
+              <a:rPr dirty="0"/>
+              <a:t>. La </a:t>
+            </a:r>
+            <a:r>
+              <a:rPr dirty="0" err="1"/>
+              <a:t>cota</a:t>
+            </a:r>
+            <a:endParaRPr dirty="0"/>
+          </a:p>
+          <a:p>
+            <a:r>
+              <a:rPr dirty="0"/>
+              <a:t>describe </a:t>
+            </a:r>
+            <a:r>
+              <a:rPr dirty="0" err="1"/>
+              <a:t>el</a:t>
+            </a:r>
+            <a:r>
+              <a:rPr dirty="0"/>
+              <a:t> </a:t>
+            </a:r>
+            <a:r>
+              <a:rPr dirty="0" err="1"/>
+              <a:t>crecimiento</a:t>
+            </a:r>
+            <a:r>
+              <a:rPr dirty="0"/>
+              <a:t>, no la </a:t>
+            </a:r>
+            <a:r>
+              <a:rPr dirty="0" err="1"/>
+              <a:t>constante</a:t>
+            </a:r>
+            <a:r>
+              <a:rPr dirty="0"/>
+              <a:t>. Ese </a:t>
+            </a:r>
+            <a:r>
+              <a:rPr dirty="0" err="1"/>
+              <a:t>contraste</a:t>
+            </a:r>
+            <a:r>
+              <a:rPr dirty="0"/>
+              <a:t> </a:t>
+            </a:r>
+            <a:r>
+              <a:rPr dirty="0" err="1"/>
+              <a:t>fue</a:t>
+            </a:r>
+            <a:r>
+              <a:rPr dirty="0"/>
+              <a:t> uno de </a:t>
+            </a:r>
+            <a:r>
+              <a:rPr dirty="0" err="1"/>
+              <a:t>los</a:t>
+            </a:r>
+            <a:r>
+              <a:rPr dirty="0"/>
+              <a:t> </a:t>
+            </a:r>
+            <a:r>
+              <a:rPr dirty="0" err="1"/>
+              <a:t>aprendizajes</a:t>
+            </a:r>
+            <a:endParaRPr dirty="0"/>
+          </a:p>
+          <a:p>
+            <a:r>
+              <a:rPr dirty="0" err="1"/>
+              <a:t>centrales</a:t>
+            </a:r>
+            <a:r>
+              <a:rPr dirty="0"/>
+              <a:t> del </a:t>
+            </a:r>
+            <a:r>
+              <a:rPr dirty="0" err="1"/>
+              <a:t>curso</a:t>
+            </a:r>
+            <a:r>
+              <a:rPr dirty="0"/>
+              <a:t>.</a:t>
+            </a:r>
+          </a:p>
+          <a:p>
+            <a:endParaRPr dirty="0"/>
+          </a:p>
+          <a:p>
+            <a:r>
+              <a:rPr dirty="0"/>
+              <a:t>SI EL VIDEO VA LARGO, </a:t>
+            </a:r>
+            <a:r>
+              <a:rPr dirty="0" err="1"/>
+              <a:t>recortar</a:t>
+            </a:r>
+            <a:r>
+              <a:rPr dirty="0"/>
+              <a:t> </a:t>
+            </a:r>
+            <a:r>
+              <a:rPr dirty="0" err="1"/>
+              <a:t>esta</a:t>
+            </a:r>
+            <a:r>
+              <a:rPr dirty="0"/>
+              <a:t> </a:t>
+            </a:r>
+            <a:r>
+              <a:rPr dirty="0" err="1"/>
+              <a:t>lámina</a:t>
+            </a:r>
+            <a:r>
+              <a:rPr dirty="0"/>
+              <a:t> a las dos </a:t>
+            </a:r>
+            <a:r>
+              <a:rPr dirty="0" err="1"/>
+              <a:t>primeras</a:t>
+            </a:r>
+            <a:r>
+              <a:rPr dirty="0"/>
+              <a:t> </a:t>
+            </a:r>
+            <a:r>
+              <a:rPr dirty="0" err="1"/>
+              <a:t>cifras</a:t>
+            </a:r>
+            <a:r>
+              <a:rPr dirty="0"/>
+              <a:t> y </a:t>
+            </a:r>
+            <a:r>
+              <a:rPr dirty="0" err="1"/>
+              <a:t>omitir</a:t>
+            </a:r>
+            <a:r>
+              <a:rPr dirty="0"/>
+              <a:t> </a:t>
+            </a:r>
+            <a:r>
+              <a:rPr dirty="0" err="1"/>
+              <a:t>el</a:t>
+            </a:r>
+            <a:r>
+              <a:rPr dirty="0"/>
+              <a:t> </a:t>
+            </a:r>
+            <a:r>
+              <a:rPr dirty="0" err="1"/>
+              <a:t>detalle</a:t>
+            </a:r>
+            <a:endParaRPr dirty="0"/>
+          </a:p>
+          <a:p>
+            <a:r>
+              <a:rPr dirty="0"/>
+              <a:t>de </a:t>
+            </a:r>
+            <a:r>
+              <a:rPr dirty="0" err="1"/>
+              <a:t>quickselect</a:t>
+            </a:r>
+            <a:r>
+              <a:rPr dirty="0"/>
+              <a:t>: </a:t>
+            </a:r>
+            <a:r>
+              <a:rPr dirty="0" err="1"/>
+              <a:t>ahorra</a:t>
+            </a:r>
+            <a:r>
+              <a:rPr dirty="0"/>
+              <a:t> </a:t>
+            </a:r>
+            <a:r>
+              <a:rPr dirty="0" err="1"/>
+              <a:t>unos</a:t>
+            </a:r>
+            <a:r>
+              <a:rPr dirty="0"/>
+              <a:t> 20 </a:t>
+            </a:r>
+            <a:r>
+              <a:rPr dirty="0" err="1"/>
+              <a:t>segundos</a:t>
+            </a:r>
+            <a:r>
+              <a:rPr dirty="0"/>
+              <a:t>.</a:t>
+            </a:r>
           </a:p>
         </p:txBody>
       </p:sp>
@@ -1133,7 +4971,454 @@
           <a:bodyPr/>
           <a:lstStyle/>
           <a:p>
+            <a:r>
+              <a:rPr dirty="0"/>
+              <a:t>En </a:t>
+            </a:r>
+            <a:r>
+              <a:rPr dirty="0" err="1"/>
+              <a:t>síntesis</a:t>
+            </a:r>
+            <a:r>
+              <a:rPr dirty="0"/>
+              <a:t>, cuatro </a:t>
+            </a:r>
+            <a:r>
+              <a:rPr dirty="0" err="1"/>
+              <a:t>conclusiones</a:t>
+            </a:r>
+            <a:r>
+              <a:rPr dirty="0"/>
+              <a:t>.</a:t>
+            </a:r>
+          </a:p>
+          <a:p>
             <a:endParaRPr dirty="0"/>
+          </a:p>
+          <a:p>
+            <a:r>
+              <a:rPr dirty="0"/>
+              <a:t>El </a:t>
+            </a:r>
+            <a:r>
+              <a:rPr dirty="0" err="1"/>
+              <a:t>rezago</a:t>
+            </a:r>
+            <a:r>
+              <a:rPr dirty="0"/>
+              <a:t> es </a:t>
+            </a:r>
+            <a:r>
+              <a:rPr dirty="0" err="1"/>
+              <a:t>masivo</a:t>
+            </a:r>
+            <a:r>
+              <a:rPr dirty="0"/>
+              <a:t> y </a:t>
+            </a:r>
+            <a:r>
+              <a:rPr dirty="0" err="1"/>
+              <a:t>estructural</a:t>
+            </a:r>
+            <a:r>
+              <a:rPr dirty="0"/>
+              <a:t>, no </a:t>
+            </a:r>
+            <a:r>
+              <a:rPr dirty="0" err="1"/>
+              <a:t>aleatorio</a:t>
+            </a:r>
+            <a:r>
+              <a:rPr dirty="0"/>
+              <a:t>.</a:t>
+            </a:r>
+          </a:p>
+          <a:p>
+            <a:endParaRPr dirty="0"/>
+          </a:p>
+          <a:p>
+            <a:r>
+              <a:rPr dirty="0"/>
+              <a:t>La pandemia </a:t>
+            </a:r>
+            <a:r>
+              <a:rPr dirty="0" err="1"/>
+              <a:t>desplazó</a:t>
+            </a:r>
+            <a:r>
+              <a:rPr dirty="0"/>
+              <a:t> </a:t>
+            </a:r>
+            <a:r>
+              <a:rPr dirty="0" err="1"/>
+              <a:t>titulaciones</a:t>
+            </a:r>
+            <a:r>
+              <a:rPr dirty="0"/>
+              <a:t> </a:t>
+            </a:r>
+            <a:r>
+              <a:rPr dirty="0" err="1"/>
+              <a:t>en</a:t>
+            </a:r>
+            <a:r>
+              <a:rPr dirty="0"/>
+              <a:t> </a:t>
+            </a:r>
+            <a:r>
+              <a:rPr dirty="0" err="1"/>
+              <a:t>lugar</a:t>
+            </a:r>
+            <a:r>
+              <a:rPr dirty="0"/>
+              <a:t> de </a:t>
+            </a:r>
+            <a:r>
+              <a:rPr dirty="0" err="1"/>
+              <a:t>empeorarlas</a:t>
+            </a:r>
+            <a:r>
+              <a:rPr dirty="0"/>
+              <a:t>.</a:t>
+            </a:r>
+          </a:p>
+          <a:p>
+            <a:endParaRPr dirty="0"/>
+          </a:p>
+          <a:p>
+            <a:r>
+              <a:rPr dirty="0"/>
+              <a:t>Los </a:t>
+            </a:r>
+            <a:r>
+              <a:rPr dirty="0" err="1"/>
+              <a:t>registros</a:t>
+            </a:r>
+            <a:r>
+              <a:rPr dirty="0"/>
+              <a:t> </a:t>
+            </a:r>
+            <a:r>
+              <a:rPr dirty="0" err="1"/>
+              <a:t>administrativos</a:t>
+            </a:r>
+            <a:r>
+              <a:rPr dirty="0"/>
+              <a:t> no </a:t>
+            </a:r>
+            <a:r>
+              <a:rPr dirty="0" err="1"/>
+              <a:t>explican</a:t>
+            </a:r>
+            <a:r>
+              <a:rPr dirty="0"/>
+              <a:t> </a:t>
+            </a:r>
+            <a:r>
+              <a:rPr dirty="0" err="1"/>
+              <a:t>el</a:t>
+            </a:r>
+            <a:r>
+              <a:rPr dirty="0"/>
+              <a:t> </a:t>
+            </a:r>
+            <a:r>
+              <a:rPr dirty="0" err="1"/>
+              <a:t>caso</a:t>
+            </a:r>
+            <a:r>
+              <a:rPr dirty="0"/>
+              <a:t> individual: </a:t>
+            </a:r>
+            <a:r>
+              <a:rPr dirty="0" err="1"/>
+              <a:t>el</a:t>
+            </a:r>
+            <a:r>
+              <a:rPr dirty="0"/>
+              <a:t> R </a:t>
+            </a:r>
+            <a:r>
+              <a:rPr dirty="0" err="1"/>
+              <a:t>cuadrado</a:t>
+            </a:r>
+            <a:r>
+              <a:rPr dirty="0"/>
+              <a:t> es de 0 coma</a:t>
+            </a:r>
+          </a:p>
+          <a:p>
+            <a:r>
+              <a:rPr dirty="0"/>
+              <a:t>085 y la </a:t>
+            </a:r>
+            <a:r>
+              <a:rPr dirty="0" err="1"/>
+              <a:t>clasificación</a:t>
+            </a:r>
+            <a:r>
+              <a:rPr dirty="0"/>
+              <a:t> no </a:t>
+            </a:r>
+            <a:r>
+              <a:rPr dirty="0" err="1"/>
+              <a:t>supera</a:t>
+            </a:r>
+            <a:r>
+              <a:rPr dirty="0"/>
+              <a:t> a </a:t>
+            </a:r>
+            <a:r>
+              <a:rPr dirty="0" err="1"/>
+              <a:t>predecir</a:t>
+            </a:r>
+            <a:r>
+              <a:rPr dirty="0"/>
+              <a:t> </a:t>
+            </a:r>
+            <a:r>
+              <a:rPr dirty="0" err="1"/>
+              <a:t>siempre</a:t>
+            </a:r>
+            <a:r>
+              <a:rPr dirty="0"/>
+              <a:t> la </a:t>
+            </a:r>
+            <a:r>
+              <a:rPr dirty="0" err="1"/>
+              <a:t>clase</a:t>
+            </a:r>
+            <a:r>
+              <a:rPr dirty="0"/>
+              <a:t> </a:t>
+            </a:r>
+            <a:r>
+              <a:rPr dirty="0" err="1"/>
+              <a:t>mayoritaria</a:t>
+            </a:r>
+            <a:r>
+              <a:rPr dirty="0"/>
+              <a:t>. </a:t>
+            </a:r>
+            <a:r>
+              <a:rPr dirty="0" err="1"/>
+              <a:t>Eso</a:t>
+            </a:r>
+            <a:r>
+              <a:rPr dirty="0"/>
+              <a:t> no es un</a:t>
+            </a:r>
+          </a:p>
+          <a:p>
+            <a:r>
+              <a:rPr dirty="0" err="1"/>
+              <a:t>fracaso</a:t>
+            </a:r>
+            <a:r>
+              <a:rPr dirty="0"/>
+              <a:t> del </a:t>
+            </a:r>
+            <a:r>
+              <a:rPr dirty="0" err="1"/>
+              <a:t>modelo</a:t>
+            </a:r>
+            <a:r>
+              <a:rPr dirty="0"/>
+              <a:t>, es un </a:t>
+            </a:r>
+            <a:r>
+              <a:rPr dirty="0" err="1"/>
+              <a:t>resultado</a:t>
+            </a:r>
+            <a:r>
+              <a:rPr dirty="0"/>
+              <a:t>: </a:t>
+            </a:r>
+            <a:r>
+              <a:rPr dirty="0" err="1"/>
+              <a:t>el</a:t>
+            </a:r>
+            <a:r>
+              <a:rPr dirty="0"/>
+              <a:t> </a:t>
+            </a:r>
+            <a:r>
+              <a:rPr dirty="0" err="1"/>
+              <a:t>rezago</a:t>
+            </a:r>
+            <a:r>
+              <a:rPr dirty="0"/>
+              <a:t> </a:t>
+            </a:r>
+            <a:r>
+              <a:rPr dirty="0" err="1"/>
+              <a:t>depende</a:t>
+            </a:r>
+            <a:r>
+              <a:rPr dirty="0"/>
+              <a:t> de </a:t>
+            </a:r>
+            <a:r>
+              <a:rPr dirty="0" err="1"/>
+              <a:t>trayectorias</a:t>
+            </a:r>
+            <a:r>
+              <a:rPr dirty="0"/>
+              <a:t> </a:t>
+            </a:r>
+            <a:r>
+              <a:rPr dirty="0" err="1"/>
+              <a:t>personales</a:t>
+            </a:r>
+            <a:r>
+              <a:rPr dirty="0"/>
+              <a:t> que</a:t>
+            </a:r>
+          </a:p>
+          <a:p>
+            <a:r>
+              <a:rPr dirty="0" err="1"/>
+              <a:t>esta</a:t>
+            </a:r>
+            <a:r>
+              <a:rPr dirty="0"/>
+              <a:t> </a:t>
+            </a:r>
+            <a:r>
+              <a:rPr dirty="0" err="1"/>
+              <a:t>fuente</a:t>
+            </a:r>
+            <a:r>
+              <a:rPr dirty="0"/>
+              <a:t> no </a:t>
+            </a:r>
+            <a:r>
+              <a:rPr dirty="0" err="1"/>
+              <a:t>registra</a:t>
+            </a:r>
+            <a:r>
+              <a:rPr dirty="0"/>
+              <a:t>.</a:t>
+            </a:r>
+          </a:p>
+          <a:p>
+            <a:endParaRPr dirty="0"/>
+          </a:p>
+          <a:p>
+            <a:r>
+              <a:rPr dirty="0"/>
+              <a:t>Y </a:t>
+            </a:r>
+            <a:r>
+              <a:rPr dirty="0" err="1"/>
+              <a:t>todo</a:t>
+            </a:r>
+            <a:r>
+              <a:rPr dirty="0"/>
+              <a:t> </a:t>
+            </a:r>
+            <a:r>
+              <a:rPr dirty="0" err="1"/>
+              <a:t>el</a:t>
+            </a:r>
+            <a:r>
+              <a:rPr dirty="0"/>
+              <a:t> </a:t>
+            </a:r>
+            <a:r>
+              <a:rPr dirty="0" err="1"/>
+              <a:t>proyecto</a:t>
+            </a:r>
+            <a:r>
+              <a:rPr dirty="0"/>
+              <a:t> es reproducible: cuatro </a:t>
+            </a:r>
+            <a:r>
+              <a:rPr dirty="0" err="1"/>
+              <a:t>comandos</a:t>
+            </a:r>
+            <a:r>
+              <a:rPr dirty="0"/>
+              <a:t> lo </a:t>
+            </a:r>
+            <a:r>
+              <a:rPr dirty="0" err="1"/>
+              <a:t>instalan</a:t>
+            </a:r>
+            <a:r>
+              <a:rPr dirty="0"/>
+              <a:t> y </a:t>
+            </a:r>
+            <a:r>
+              <a:rPr dirty="0" err="1"/>
+              <a:t>ejecutan</a:t>
+            </a:r>
+            <a:r>
+              <a:rPr dirty="0"/>
+              <a:t>, con 45</a:t>
+            </a:r>
+          </a:p>
+          <a:p>
+            <a:r>
+              <a:rPr dirty="0"/>
+              <a:t>commits </a:t>
+            </a:r>
+            <a:r>
+              <a:rPr dirty="0" err="1"/>
+              <a:t>verificables</a:t>
+            </a:r>
+            <a:r>
+              <a:rPr dirty="0"/>
+              <a:t> y </a:t>
+            </a:r>
+            <a:r>
+              <a:rPr dirty="0" err="1"/>
+              <a:t>cada</a:t>
+            </a:r>
+            <a:r>
+              <a:rPr dirty="0"/>
+              <a:t> </a:t>
+            </a:r>
+            <a:r>
+              <a:rPr dirty="0" err="1"/>
+              <a:t>cifra</a:t>
+            </a:r>
+            <a:r>
+              <a:rPr dirty="0"/>
+              <a:t> </a:t>
+            </a:r>
+            <a:r>
+              <a:rPr dirty="0" err="1"/>
+              <a:t>rastreable</a:t>
+            </a:r>
+            <a:r>
+              <a:rPr dirty="0"/>
+              <a:t> hasta </a:t>
+            </a:r>
+            <a:r>
+              <a:rPr dirty="0" err="1"/>
+              <a:t>el</a:t>
+            </a:r>
+            <a:r>
+              <a:rPr dirty="0"/>
+              <a:t> </a:t>
+            </a:r>
+            <a:r>
+              <a:rPr dirty="0" err="1"/>
+              <a:t>archivo</a:t>
+            </a:r>
+            <a:r>
+              <a:rPr dirty="0"/>
+              <a:t> que la </a:t>
+            </a:r>
+            <a:r>
+              <a:rPr dirty="0" err="1"/>
+              <a:t>generó</a:t>
+            </a:r>
+            <a:r>
+              <a:rPr dirty="0"/>
+              <a:t>.</a:t>
+            </a:r>
           </a:p>
         </p:txBody>
       </p:sp>

</xml_diff>